<commit_message>
Add validated AV-ASD video upload and update final research documents
</commit_message>
<xml_diff>
--- a/presentations/FINAL_RESEARCH_PRESENTATION.pptx
+++ b/presentations/FINAL_RESEARCH_PRESENTATION.pptx
@@ -2,24 +2,26 @@
 <file path=ppt/presentation.xml><?xml version="1.0" encoding="utf-8"?>
 <p:presentation xmlns:p="http://schemas.openxmlformats.org/presentationml/2006/main">
   <p:sldMasterIdLst>
-    <p:sldMasterId xmlns:r="http://schemas.openxmlformats.org/officeDocument/2006/relationships" id="2147483648" r:id="R796214dc0da846a7"/>
+    <p:sldMasterId xmlns:r="http://schemas.openxmlformats.org/officeDocument/2006/relationships" id="2147483648" r:id="R1bd40e4d02914e67"/>
   </p:sldMasterIdLst>
   <p:notesMasterIdLst>
-    <p:notesMasterId xmlns:r="http://schemas.openxmlformats.org/officeDocument/2006/relationships" r:id="R8edcbb9cf45b4781"/>
+    <p:notesMasterId xmlns:r="http://schemas.openxmlformats.org/officeDocument/2006/relationships" r:id="R39c42a42a5d448b8"/>
   </p:notesMasterIdLst>
   <p:sldIdLst>
-    <p:sldId xmlns:r="http://schemas.openxmlformats.org/officeDocument/2006/relationships" id="256" r:id="Re7b71863a7444fca"/>
-    <p:sldId xmlns:r="http://schemas.openxmlformats.org/officeDocument/2006/relationships" id="257" r:id="R1e3d58f89fdc44e2"/>
-    <p:sldId xmlns:r="http://schemas.openxmlformats.org/officeDocument/2006/relationships" id="258" r:id="R4f3c0d4200f34d80"/>
-    <p:sldId xmlns:r="http://schemas.openxmlformats.org/officeDocument/2006/relationships" id="259" r:id="Rc6eec8418e59483b"/>
-    <p:sldId xmlns:r="http://schemas.openxmlformats.org/officeDocument/2006/relationships" id="260" r:id="R17073f3587164049"/>
-    <p:sldId xmlns:r="http://schemas.openxmlformats.org/officeDocument/2006/relationships" id="261" r:id="R11fdb68dce4d4562"/>
-    <p:sldId xmlns:r="http://schemas.openxmlformats.org/officeDocument/2006/relationships" id="262" r:id="R28760837a7c24e67"/>
-    <p:sldId xmlns:r="http://schemas.openxmlformats.org/officeDocument/2006/relationships" id="263" r:id="R9127a08d23294e27"/>
-    <p:sldId xmlns:r="http://schemas.openxmlformats.org/officeDocument/2006/relationships" id="264" r:id="R3edc14e340184726"/>
-    <p:sldId xmlns:r="http://schemas.openxmlformats.org/officeDocument/2006/relationships" id="265" r:id="R4e19fe46e370452e"/>
-    <p:sldId xmlns:r="http://schemas.openxmlformats.org/officeDocument/2006/relationships" id="266" r:id="Rd4877f62981f4349"/>
-    <p:sldId xmlns:r="http://schemas.openxmlformats.org/officeDocument/2006/relationships" id="267" r:id="Rc78cf22178074ebe"/>
+    <p:sldId xmlns:r="http://schemas.openxmlformats.org/officeDocument/2006/relationships" id="256" r:id="R094f9d3e27764c80"/>
+    <p:sldId xmlns:r="http://schemas.openxmlformats.org/officeDocument/2006/relationships" id="257" r:id="Rafe67b2477a54826"/>
+    <p:sldId xmlns:r="http://schemas.openxmlformats.org/officeDocument/2006/relationships" id="258" r:id="Re5df9012ce7a4ce5"/>
+    <p:sldId xmlns:r="http://schemas.openxmlformats.org/officeDocument/2006/relationships" id="259" r:id="R783993fcf4074ea5"/>
+    <p:sldId xmlns:r="http://schemas.openxmlformats.org/officeDocument/2006/relationships" id="260" r:id="R1c6d2f6e85824d7c"/>
+    <p:sldId xmlns:r="http://schemas.openxmlformats.org/officeDocument/2006/relationships" id="261" r:id="R97503d3a7d16407c"/>
+    <p:sldId xmlns:r="http://schemas.openxmlformats.org/officeDocument/2006/relationships" id="262" r:id="R3a5065e2a4f44d5d"/>
+    <p:sldId xmlns:r="http://schemas.openxmlformats.org/officeDocument/2006/relationships" id="263" r:id="R1392c667fdbc4400"/>
+    <p:sldId xmlns:r="http://schemas.openxmlformats.org/officeDocument/2006/relationships" id="264" r:id="Re336de287b1e4998"/>
+    <p:sldId xmlns:r="http://schemas.openxmlformats.org/officeDocument/2006/relationships" id="265" r:id="Rb703473fcb0544a7"/>
+    <p:sldId xmlns:r="http://schemas.openxmlformats.org/officeDocument/2006/relationships" id="266" r:id="R59de15a69cf84413"/>
+    <p:sldId xmlns:r="http://schemas.openxmlformats.org/officeDocument/2006/relationships" id="267" r:id="R2d6ce3604c904c63"/>
+    <p:sldId xmlns:r="http://schemas.openxmlformats.org/officeDocument/2006/relationships" id="268" r:id="R6f13453636da4c42"/>
+    <p:sldId xmlns:r="http://schemas.openxmlformats.org/officeDocument/2006/relationships" id="269" r:id="R03658586a6814e79"/>
   </p:sldIdLst>
   <p:sldSz cx="12192000" cy="6858000"/>
   <p:notesSz cx="6858000" cy="9144000"/>
@@ -663,7 +665,147 @@
           <a:lstStyle xmlns:a="http://schemas.openxmlformats.org/drawingml/2006/main"/>
           <a:p xmlns:a="http://schemas.openxmlformats.org/drawingml/2006/main">
             <a:r>
-              <a:t>Source: consolidated review and handoff. No claim of clinical utility or arbitrary media compatibility. Release license and bibliography verification remain publication gates.</a:t>
+              <a:t>AV-ASD workflow only; it does not generate I3D or human-coded inputs for ASD-FEAT. Sources: docs/VIDEO_UPLOAD_FINAL_STATUS.md; results/video_upload_validation/20261011T194344_005289Z/validation.json; user-inspected HTML exports. Above-threshold predictions are not confirmed behaviors; scores are not clinical probabilities.</a:t>
+            </a:r>
+          </a:p>
+        </p:txBody>
+      </p:sp>
+      <p:sp>
+        <p:nvSpPr>
+          <p:cNvPr id="4" name="Slide Number Placeholder 3"/>
+          <p:cNvSpPr>
+            <a:spLocks xmlns:a="http://schemas.openxmlformats.org/drawingml/2006/main" noGrp="1"/>
+          </p:cNvSpPr>
+          <p:nvPr>
+            <p:ph type="sldNum" idx="5"/>
+          </p:nvPr>
+        </p:nvSpPr>
+        <p:spPr/>
+        <p:txBody>
+          <a:bodyPr xmlns:a="http://schemas.openxmlformats.org/drawingml/2006/main"/>
+          <a:lstStyle xmlns:a="http://schemas.openxmlformats.org/drawingml/2006/main"/>
+          <a:p xmlns:a="http://schemas.openxmlformats.org/drawingml/2006/main"/>
+        </p:txBody>
+      </p:sp>
+    </p:spTree>
+  </p:cSld>
+  <p:clrMapOvr>
+    <a:masterClrMapping xmlns:a="http://schemas.openxmlformats.org/drawingml/2006/main"/>
+  </p:clrMapOvr>
+</p:notes>
+</file>
+
+<file path=ppt/notesSlides/notesSlide13.xml><?xml version="1.0" encoding="utf-8"?>
+<p:notes xmlns:p="http://schemas.openxmlformats.org/presentationml/2006/main">
+  <p:cSld>
+    <p:spTree>
+      <p:nvGrpSpPr>
+        <p:cNvPr id="1" name=""/>
+        <p:cNvGrpSpPr/>
+        <p:nvPr/>
+      </p:nvGrpSpPr>
+      <p:grpSpPr>
+        <a:xfrm xmlns:a="http://schemas.openxmlformats.org/drawingml/2006/main"/>
+      </p:grpSpPr>
+      <p:sp>
+        <p:nvSpPr>
+          <p:cNvPr id="2" name="Slide Image Placeholder 1"/>
+          <p:cNvSpPr>
+            <a:spLocks xmlns:a="http://schemas.openxmlformats.org/drawingml/2006/main" noGrp="1"/>
+          </p:cNvSpPr>
+          <p:nvPr>
+            <p:ph type="sldImg" idx="0"/>
+          </p:nvPr>
+        </p:nvSpPr>
+        <p:spPr/>
+      </p:sp>
+      <p:sp>
+        <p:nvSpPr>
+          <p:cNvPr id="3" name="Notes Placeholder 2"/>
+          <p:cNvSpPr>
+            <a:spLocks xmlns:a="http://schemas.openxmlformats.org/drawingml/2006/main" noGrp="1"/>
+          </p:cNvSpPr>
+          <p:nvPr>
+            <p:ph type="body" idx="1"/>
+          </p:nvPr>
+        </p:nvSpPr>
+        <p:spPr/>
+        <p:txBody>
+          <a:bodyPr xmlns:a="http://schemas.openxmlformats.org/drawingml/2006/main"/>
+          <a:lstStyle xmlns:a="http://schemas.openxmlformats.org/drawingml/2006/main"/>
+          <a:p xmlns:a="http://schemas.openxmlformats.org/drawingml/2006/main">
+            <a:r>
+              <a:t>Evidence: results/video_upload_validation/20261011T194344_005289Z/validation.json; results/video_upload_cases/20261011T195412_015353Z/upload_case_validation.json; results/video_upload_explanations/20261011T202257_847333Z/validation.json. Exported HTML summary and ten explanation tables inspected; clearing previous report confirmed by the user. No fitting or tuning occurred.</a:t>
+            </a:r>
+          </a:p>
+        </p:txBody>
+      </p:sp>
+      <p:sp>
+        <p:nvSpPr>
+          <p:cNvPr id="4" name="Slide Number Placeholder 3"/>
+          <p:cNvSpPr>
+            <a:spLocks xmlns:a="http://schemas.openxmlformats.org/drawingml/2006/main" noGrp="1"/>
+          </p:cNvSpPr>
+          <p:nvPr>
+            <p:ph type="sldNum" idx="5"/>
+          </p:nvPr>
+        </p:nvSpPr>
+        <p:spPr/>
+        <p:txBody>
+          <a:bodyPr xmlns:a="http://schemas.openxmlformats.org/drawingml/2006/main"/>
+          <a:lstStyle xmlns:a="http://schemas.openxmlformats.org/drawingml/2006/main"/>
+          <a:p xmlns:a="http://schemas.openxmlformats.org/drawingml/2006/main"/>
+        </p:txBody>
+      </p:sp>
+    </p:spTree>
+  </p:cSld>
+  <p:clrMapOvr>
+    <a:masterClrMapping xmlns:a="http://schemas.openxmlformats.org/drawingml/2006/main"/>
+  </p:clrMapOvr>
+</p:notes>
+</file>
+
+<file path=ppt/notesSlides/notesSlide14.xml><?xml version="1.0" encoding="utf-8"?>
+<p:notes xmlns:p="http://schemas.openxmlformats.org/presentationml/2006/main">
+  <p:cSld>
+    <p:spTree>
+      <p:nvGrpSpPr>
+        <p:cNvPr id="1" name=""/>
+        <p:cNvGrpSpPr/>
+        <p:nvPr/>
+      </p:nvGrpSpPr>
+      <p:grpSpPr>
+        <a:xfrm xmlns:a="http://schemas.openxmlformats.org/drawingml/2006/main"/>
+      </p:grpSpPr>
+      <p:sp>
+        <p:nvSpPr>
+          <p:cNvPr id="2" name="Slide Image Placeholder 1"/>
+          <p:cNvSpPr>
+            <a:spLocks xmlns:a="http://schemas.openxmlformats.org/drawingml/2006/main" noGrp="1"/>
+          </p:cNvSpPr>
+          <p:nvPr>
+            <p:ph type="sldImg" idx="0"/>
+          </p:nvPr>
+        </p:nvSpPr>
+        <p:spPr/>
+      </p:sp>
+      <p:sp>
+        <p:nvSpPr>
+          <p:cNvPr id="3" name="Notes Placeholder 2"/>
+          <p:cNvSpPr>
+            <a:spLocks xmlns:a="http://schemas.openxmlformats.org/drawingml/2006/main" noGrp="1"/>
+          </p:cNvSpPr>
+          <p:nvPr>
+            <p:ph type="body" idx="1"/>
+          </p:nvPr>
+        </p:nvSpPr>
+        <p:spPr/>
+        <p:txBody>
+          <a:bodyPr xmlns:a="http://schemas.openxmlformats.org/drawingml/2006/main"/>
+          <a:lstStyle xmlns:a="http://schemas.openxmlformats.org/drawingml/2006/main"/>
+          <a:p xmlns:a="http://schemas.openxmlformats.org/drawingml/2006/main">
+            <a:r>
+              <a:t>Existing research conclusions preserved. MP4 upload is implemented only for the handcrafted AV-ASD baseline. ASD-FEAT raw-media extraction, clinical diagnosis/severity and calibrated risk are not established.</a:t>
             </a:r>
           </a:p>
         </p:txBody>
@@ -1321,6 +1463,7 @@
                 <a:spcPts val="0"/>
               </a:spcAft>
               <a:buNone/>
+              <a:defRPr/>
             </a:lvl1pPr>
             <a:lvl2pPr marL="0" indent="0">
               <a:lnSpc>
@@ -1333,6 +1476,7 @@
                 <a:spcPts val="0"/>
               </a:spcAft>
               <a:buNone/>
+              <a:defRPr/>
             </a:lvl2pPr>
             <a:lvl3pPr marL="0" indent="0">
               <a:lnSpc>
@@ -1345,6 +1489,7 @@
                 <a:spcPts val="0"/>
               </a:spcAft>
               <a:buNone/>
+              <a:defRPr/>
             </a:lvl3pPr>
             <a:lvl4pPr marL="0" indent="0">
               <a:lnSpc>
@@ -1357,6 +1502,7 @@
                 <a:spcPts val="0"/>
               </a:spcAft>
               <a:buNone/>
+              <a:defRPr/>
             </a:lvl4pPr>
             <a:lvl5pPr marL="0" indent="0">
               <a:lnSpc>
@@ -1369,6 +1515,7 @@
                 <a:spcPts val="0"/>
               </a:spcAft>
               <a:buNone/>
+              <a:defRPr/>
             </a:lvl5pPr>
             <a:lvl6pPr marL="0" indent="0">
               <a:lnSpc>
@@ -1381,6 +1528,7 @@
                 <a:spcPts val="0"/>
               </a:spcAft>
               <a:buNone/>
+              <a:defRPr/>
             </a:lvl6pPr>
             <a:lvl7pPr marL="0" indent="0">
               <a:lnSpc>
@@ -1393,6 +1541,7 @@
                 <a:spcPts val="0"/>
               </a:spcAft>
               <a:buNone/>
+              <a:defRPr/>
             </a:lvl7pPr>
             <a:lvl8pPr marL="0" indent="0">
               <a:lnSpc>
@@ -1405,6 +1554,7 @@
                 <a:spcPts val="0"/>
               </a:spcAft>
               <a:buNone/>
+              <a:defRPr/>
             </a:lvl8pPr>
             <a:lvl9pPr marL="0" indent="0">
               <a:lnSpc>
@@ -1417,6 +1567,7 @@
                 <a:spcPts val="0"/>
               </a:spcAft>
               <a:buNone/>
+              <a:defRPr/>
             </a:lvl9pPr>
           </a:lstStyle>
           <a:p xmlns:a="http://schemas.openxmlformats.org/drawingml/2006/main"/>
@@ -1478,6 +1629,7 @@
                 <a:spcPts val="0"/>
               </a:spcAft>
               <a:buNone/>
+              <a:defRPr/>
             </a:lvl1pPr>
             <a:lvl2pPr marL="0" indent="0">
               <a:lnSpc>
@@ -1490,6 +1642,7 @@
                 <a:spcPts val="0"/>
               </a:spcAft>
               <a:buNone/>
+              <a:defRPr/>
             </a:lvl2pPr>
             <a:lvl3pPr marL="0" indent="0">
               <a:lnSpc>
@@ -1502,6 +1655,7 @@
                 <a:spcPts val="0"/>
               </a:spcAft>
               <a:buNone/>
+              <a:defRPr/>
             </a:lvl3pPr>
             <a:lvl4pPr marL="0" indent="0">
               <a:lnSpc>
@@ -1514,6 +1668,7 @@
                 <a:spcPts val="0"/>
               </a:spcAft>
               <a:buNone/>
+              <a:defRPr/>
             </a:lvl4pPr>
             <a:lvl5pPr marL="0" indent="0">
               <a:lnSpc>
@@ -1526,6 +1681,7 @@
                 <a:spcPts val="0"/>
               </a:spcAft>
               <a:buNone/>
+              <a:defRPr/>
             </a:lvl5pPr>
             <a:lvl6pPr marL="0" indent="0">
               <a:lnSpc>
@@ -1538,6 +1694,7 @@
                 <a:spcPts val="0"/>
               </a:spcAft>
               <a:buNone/>
+              <a:defRPr/>
             </a:lvl6pPr>
             <a:lvl7pPr marL="0" indent="0">
               <a:lnSpc>
@@ -1550,6 +1707,7 @@
                 <a:spcPts val="0"/>
               </a:spcAft>
               <a:buNone/>
+              <a:defRPr/>
             </a:lvl7pPr>
             <a:lvl8pPr marL="0" indent="0">
               <a:lnSpc>
@@ -1562,6 +1720,7 @@
                 <a:spcPts val="0"/>
               </a:spcAft>
               <a:buNone/>
+              <a:defRPr/>
             </a:lvl8pPr>
             <a:lvl9pPr marL="0" indent="0">
               <a:lnSpc>
@@ -1574,6 +1733,7 @@
                 <a:spcPts val="0"/>
               </a:spcAft>
               <a:buNone/>
+              <a:defRPr/>
             </a:lvl9pPr>
           </a:lstStyle>
           <a:p xmlns:a="http://schemas.openxmlformats.org/drawingml/2006/main"/>
@@ -1652,6 +1812,7 @@
                 <a:spcPts val="0"/>
               </a:spcAft>
               <a:buNone/>
+              <a:defRPr/>
             </a:lvl1pPr>
             <a:lvl2pPr marL="0" indent="0">
               <a:lnSpc>
@@ -1664,6 +1825,7 @@
                 <a:spcPts val="0"/>
               </a:spcAft>
               <a:buNone/>
+              <a:defRPr/>
             </a:lvl2pPr>
             <a:lvl3pPr marL="0" indent="0">
               <a:lnSpc>
@@ -1676,6 +1838,7 @@
                 <a:spcPts val="0"/>
               </a:spcAft>
               <a:buNone/>
+              <a:defRPr/>
             </a:lvl3pPr>
             <a:lvl4pPr marL="0" indent="0">
               <a:lnSpc>
@@ -1688,6 +1851,7 @@
                 <a:spcPts val="0"/>
               </a:spcAft>
               <a:buNone/>
+              <a:defRPr/>
             </a:lvl4pPr>
             <a:lvl5pPr marL="0" indent="0">
               <a:lnSpc>
@@ -1700,6 +1864,7 @@
                 <a:spcPts val="0"/>
               </a:spcAft>
               <a:buNone/>
+              <a:defRPr/>
             </a:lvl5pPr>
             <a:lvl6pPr marL="0" indent="0">
               <a:lnSpc>
@@ -1712,6 +1877,7 @@
                 <a:spcPts val="0"/>
               </a:spcAft>
               <a:buNone/>
+              <a:defRPr/>
             </a:lvl6pPr>
             <a:lvl7pPr marL="0" indent="0">
               <a:lnSpc>
@@ -1724,6 +1890,7 @@
                 <a:spcPts val="0"/>
               </a:spcAft>
               <a:buNone/>
+              <a:defRPr/>
             </a:lvl7pPr>
             <a:lvl8pPr marL="0" indent="0">
               <a:lnSpc>
@@ -1736,6 +1903,7 @@
                 <a:spcPts val="0"/>
               </a:spcAft>
               <a:buNone/>
+              <a:defRPr/>
             </a:lvl8pPr>
             <a:lvl9pPr marL="0" indent="0">
               <a:lnSpc>
@@ -1748,6 +1916,7 @@
                 <a:spcPts val="0"/>
               </a:spcAft>
               <a:buNone/>
+              <a:defRPr/>
             </a:lvl9pPr>
           </a:lstStyle>
           <a:p xmlns:a="http://schemas.openxmlformats.org/drawingml/2006/main"/>
@@ -1826,6 +1995,7 @@
                 <a:spcPts val="0"/>
               </a:spcAft>
               <a:buNone/>
+              <a:defRPr/>
             </a:lvl1pPr>
             <a:lvl2pPr marL="0" indent="0">
               <a:lnSpc>
@@ -1838,6 +2008,7 @@
                 <a:spcPts val="0"/>
               </a:spcAft>
               <a:buNone/>
+              <a:defRPr/>
             </a:lvl2pPr>
             <a:lvl3pPr marL="0" indent="0">
               <a:lnSpc>
@@ -1850,6 +2021,7 @@
                 <a:spcPts val="0"/>
               </a:spcAft>
               <a:buNone/>
+              <a:defRPr/>
             </a:lvl3pPr>
             <a:lvl4pPr marL="0" indent="0">
               <a:lnSpc>
@@ -1862,6 +2034,7 @@
                 <a:spcPts val="0"/>
               </a:spcAft>
               <a:buNone/>
+              <a:defRPr/>
             </a:lvl4pPr>
             <a:lvl5pPr marL="0" indent="0">
               <a:lnSpc>
@@ -1874,6 +2047,7 @@
                 <a:spcPts val="0"/>
               </a:spcAft>
               <a:buNone/>
+              <a:defRPr/>
             </a:lvl5pPr>
             <a:lvl6pPr marL="0" indent="0">
               <a:lnSpc>
@@ -1886,6 +2060,7 @@
                 <a:spcPts val="0"/>
               </a:spcAft>
               <a:buNone/>
+              <a:defRPr/>
             </a:lvl6pPr>
             <a:lvl7pPr marL="0" indent="0">
               <a:lnSpc>
@@ -1898,6 +2073,7 @@
                 <a:spcPts val="0"/>
               </a:spcAft>
               <a:buNone/>
+              <a:defRPr/>
             </a:lvl7pPr>
             <a:lvl8pPr marL="0" indent="0">
               <a:lnSpc>
@@ -1910,6 +2086,7 @@
                 <a:spcPts val="0"/>
               </a:spcAft>
               <a:buNone/>
+              <a:defRPr/>
             </a:lvl8pPr>
             <a:lvl9pPr marL="0" indent="0">
               <a:lnSpc>
@@ -1922,6 +2099,7 @@
                 <a:spcPts val="0"/>
               </a:spcAft>
               <a:buNone/>
+              <a:defRPr/>
             </a:lvl9pPr>
           </a:lstStyle>
           <a:p xmlns:a="http://schemas.openxmlformats.org/drawingml/2006/main"/>
@@ -1983,6 +2161,7 @@
                 <a:spcPts val="1200"/>
               </a:spcAft>
               <a:buChar char="•"/>
+              <a:defRPr/>
             </a:lvl1pPr>
             <a:lvl2pPr marL="533400" indent="-228600">
               <a:lnSpc>
@@ -1995,6 +2174,7 @@
                 <a:spcPts val="1200"/>
               </a:spcAft>
               <a:buChar char="•"/>
+              <a:defRPr/>
             </a:lvl2pPr>
             <a:lvl3pPr marL="838200" indent="-228600">
               <a:lnSpc>
@@ -2007,6 +2187,7 @@
                 <a:spcPts val="1200"/>
               </a:spcAft>
               <a:buChar char="•"/>
+              <a:defRPr/>
             </a:lvl3pPr>
             <a:lvl4pPr marL="1143000" indent="-228600">
               <a:lnSpc>
@@ -2019,6 +2200,7 @@
                 <a:spcPts val="1200"/>
               </a:spcAft>
               <a:buChar char="•"/>
+              <a:defRPr/>
             </a:lvl4pPr>
             <a:lvl5pPr marL="1447800" indent="-228600">
               <a:lnSpc>
@@ -2031,6 +2213,7 @@
                 <a:spcPts val="1200"/>
               </a:spcAft>
               <a:buChar char="•"/>
+              <a:defRPr/>
             </a:lvl5pPr>
             <a:lvl6pPr marL="1752600" indent="-228600">
               <a:lnSpc>
@@ -2043,6 +2226,7 @@
                 <a:spcPts val="1200"/>
               </a:spcAft>
               <a:buChar char="•"/>
+              <a:defRPr/>
             </a:lvl6pPr>
             <a:lvl7pPr marL="2057400" indent="-228600">
               <a:lnSpc>
@@ -2055,6 +2239,7 @@
                 <a:spcPts val="1200"/>
               </a:spcAft>
               <a:buChar char="•"/>
+              <a:defRPr/>
             </a:lvl7pPr>
             <a:lvl8pPr marL="2362200" indent="-228600">
               <a:lnSpc>
@@ -2067,6 +2252,7 @@
                 <a:spcPts val="1200"/>
               </a:spcAft>
               <a:buChar char="•"/>
+              <a:defRPr/>
             </a:lvl8pPr>
             <a:lvl9pPr marL="2667000" indent="-228600">
               <a:lnSpc>
@@ -2079,6 +2265,7 @@
                 <a:spcPts val="1200"/>
               </a:spcAft>
               <a:buChar char="•"/>
+              <a:defRPr/>
             </a:lvl9pPr>
           </a:lstStyle>
           <a:p xmlns:a="http://schemas.openxmlformats.org/drawingml/2006/main"/>
@@ -2157,6 +2344,7 @@
                 <a:spcPts val="0"/>
               </a:spcAft>
               <a:buNone/>
+              <a:defRPr/>
             </a:lvl1pPr>
             <a:lvl2pPr marL="0" indent="0">
               <a:lnSpc>
@@ -2169,6 +2357,7 @@
                 <a:spcPts val="0"/>
               </a:spcAft>
               <a:buNone/>
+              <a:defRPr/>
             </a:lvl2pPr>
             <a:lvl3pPr marL="0" indent="0">
               <a:lnSpc>
@@ -2181,6 +2370,7 @@
                 <a:spcPts val="0"/>
               </a:spcAft>
               <a:buNone/>
+              <a:defRPr/>
             </a:lvl3pPr>
             <a:lvl4pPr marL="0" indent="0">
               <a:lnSpc>
@@ -2193,6 +2383,7 @@
                 <a:spcPts val="0"/>
               </a:spcAft>
               <a:buNone/>
+              <a:defRPr/>
             </a:lvl4pPr>
             <a:lvl5pPr marL="0" indent="0">
               <a:lnSpc>
@@ -2205,6 +2396,7 @@
                 <a:spcPts val="0"/>
               </a:spcAft>
               <a:buNone/>
+              <a:defRPr/>
             </a:lvl5pPr>
             <a:lvl6pPr marL="0" indent="0">
               <a:lnSpc>
@@ -2217,6 +2409,7 @@
                 <a:spcPts val="0"/>
               </a:spcAft>
               <a:buNone/>
+              <a:defRPr/>
             </a:lvl6pPr>
             <a:lvl7pPr marL="0" indent="0">
               <a:lnSpc>
@@ -2229,6 +2422,7 @@
                 <a:spcPts val="0"/>
               </a:spcAft>
               <a:buNone/>
+              <a:defRPr/>
             </a:lvl7pPr>
             <a:lvl8pPr marL="0" indent="0">
               <a:lnSpc>
@@ -2241,6 +2435,7 @@
                 <a:spcPts val="0"/>
               </a:spcAft>
               <a:buNone/>
+              <a:defRPr/>
             </a:lvl8pPr>
             <a:lvl9pPr marL="0" indent="0">
               <a:lnSpc>
@@ -2253,6 +2448,7 @@
                 <a:spcPts val="0"/>
               </a:spcAft>
               <a:buNone/>
+              <a:defRPr/>
             </a:lvl9pPr>
           </a:lstStyle>
           <a:p xmlns:a="http://schemas.openxmlformats.org/drawingml/2006/main"/>
@@ -2314,6 +2510,7 @@
                 <a:spcPts val="1200"/>
               </a:spcAft>
               <a:buChar char="•"/>
+              <a:defRPr/>
             </a:lvl1pPr>
             <a:lvl2pPr marL="533400" indent="-228600">
               <a:lnSpc>
@@ -2326,6 +2523,7 @@
                 <a:spcPts val="1200"/>
               </a:spcAft>
               <a:buChar char="•"/>
+              <a:defRPr/>
             </a:lvl2pPr>
             <a:lvl3pPr marL="838200" indent="-228600">
               <a:lnSpc>
@@ -2338,6 +2536,7 @@
                 <a:spcPts val="1200"/>
               </a:spcAft>
               <a:buChar char="•"/>
+              <a:defRPr/>
             </a:lvl3pPr>
             <a:lvl4pPr marL="1143000" indent="-228600">
               <a:lnSpc>
@@ -2350,6 +2549,7 @@
                 <a:spcPts val="1200"/>
               </a:spcAft>
               <a:buChar char="•"/>
+              <a:defRPr/>
             </a:lvl4pPr>
             <a:lvl5pPr marL="1447800" indent="-228600">
               <a:lnSpc>
@@ -2362,6 +2562,7 @@
                 <a:spcPts val="1200"/>
               </a:spcAft>
               <a:buChar char="•"/>
+              <a:defRPr/>
             </a:lvl5pPr>
             <a:lvl6pPr marL="1752600" indent="-228600">
               <a:lnSpc>
@@ -2374,6 +2575,7 @@
                 <a:spcPts val="1200"/>
               </a:spcAft>
               <a:buChar char="•"/>
+              <a:defRPr/>
             </a:lvl6pPr>
             <a:lvl7pPr marL="2057400" indent="-228600">
               <a:lnSpc>
@@ -2386,6 +2588,7 @@
                 <a:spcPts val="1200"/>
               </a:spcAft>
               <a:buChar char="•"/>
+              <a:defRPr/>
             </a:lvl7pPr>
             <a:lvl8pPr marL="2362200" indent="-228600">
               <a:lnSpc>
@@ -2398,6 +2601,7 @@
                 <a:spcPts val="1200"/>
               </a:spcAft>
               <a:buChar char="•"/>
+              <a:defRPr/>
             </a:lvl8pPr>
             <a:lvl9pPr marL="2667000" indent="-228600">
               <a:lnSpc>
@@ -2410,6 +2614,7 @@
                 <a:spcPts val="1200"/>
               </a:spcAft>
               <a:buChar char="•"/>
+              <a:defRPr/>
             </a:lvl9pPr>
           </a:lstStyle>
           <a:p xmlns:a="http://schemas.openxmlformats.org/drawingml/2006/main"/>
@@ -2471,6 +2676,7 @@
                 <a:spcPts val="1200"/>
               </a:spcAft>
               <a:buChar char="•"/>
+              <a:defRPr/>
             </a:lvl1pPr>
             <a:lvl2pPr marL="533400" indent="-228600">
               <a:lnSpc>
@@ -2483,6 +2689,7 @@
                 <a:spcPts val="1200"/>
               </a:spcAft>
               <a:buChar char="•"/>
+              <a:defRPr/>
             </a:lvl2pPr>
             <a:lvl3pPr marL="838200" indent="-228600">
               <a:lnSpc>
@@ -2495,6 +2702,7 @@
                 <a:spcPts val="1200"/>
               </a:spcAft>
               <a:buChar char="•"/>
+              <a:defRPr/>
             </a:lvl3pPr>
             <a:lvl4pPr marL="1143000" indent="-228600">
               <a:lnSpc>
@@ -2507,6 +2715,7 @@
                 <a:spcPts val="1200"/>
               </a:spcAft>
               <a:buChar char="•"/>
+              <a:defRPr/>
             </a:lvl4pPr>
             <a:lvl5pPr marL="1447800" indent="-228600">
               <a:lnSpc>
@@ -2519,6 +2728,7 @@
                 <a:spcPts val="1200"/>
               </a:spcAft>
               <a:buChar char="•"/>
+              <a:defRPr/>
             </a:lvl5pPr>
             <a:lvl6pPr marL="1752600" indent="-228600">
               <a:lnSpc>
@@ -2531,6 +2741,7 @@
                 <a:spcPts val="1200"/>
               </a:spcAft>
               <a:buChar char="•"/>
+              <a:defRPr/>
             </a:lvl6pPr>
             <a:lvl7pPr marL="2057400" indent="-228600">
               <a:lnSpc>
@@ -2543,6 +2754,7 @@
                 <a:spcPts val="1200"/>
               </a:spcAft>
               <a:buChar char="•"/>
+              <a:defRPr/>
             </a:lvl7pPr>
             <a:lvl8pPr marL="2362200" indent="-228600">
               <a:lnSpc>
@@ -2555,6 +2767,7 @@
                 <a:spcPts val="1200"/>
               </a:spcAft>
               <a:buChar char="•"/>
+              <a:defRPr/>
             </a:lvl8pPr>
             <a:lvl9pPr marL="2667000" indent="-228600">
               <a:lnSpc>
@@ -2567,6 +2780,7 @@
                 <a:spcPts val="1200"/>
               </a:spcAft>
               <a:buChar char="•"/>
+              <a:defRPr/>
             </a:lvl9pPr>
           </a:lstStyle>
           <a:p xmlns:a="http://schemas.openxmlformats.org/drawingml/2006/main"/>
@@ -2645,6 +2859,7 @@
                 <a:spcPts val="0"/>
               </a:spcAft>
               <a:buNone/>
+              <a:defRPr/>
             </a:lvl1pPr>
             <a:lvl2pPr marL="0" indent="0">
               <a:lnSpc>
@@ -2657,6 +2872,7 @@
                 <a:spcPts val="0"/>
               </a:spcAft>
               <a:buNone/>
+              <a:defRPr/>
             </a:lvl2pPr>
             <a:lvl3pPr marL="0" indent="0">
               <a:lnSpc>
@@ -2669,6 +2885,7 @@
                 <a:spcPts val="0"/>
               </a:spcAft>
               <a:buNone/>
+              <a:defRPr/>
             </a:lvl3pPr>
             <a:lvl4pPr marL="0" indent="0">
               <a:lnSpc>
@@ -2681,6 +2898,7 @@
                 <a:spcPts val="0"/>
               </a:spcAft>
               <a:buNone/>
+              <a:defRPr/>
             </a:lvl4pPr>
             <a:lvl5pPr marL="0" indent="0">
               <a:lnSpc>
@@ -2693,6 +2911,7 @@
                 <a:spcPts val="0"/>
               </a:spcAft>
               <a:buNone/>
+              <a:defRPr/>
             </a:lvl5pPr>
             <a:lvl6pPr marL="0" indent="0">
               <a:lnSpc>
@@ -2705,6 +2924,7 @@
                 <a:spcPts val="0"/>
               </a:spcAft>
               <a:buNone/>
+              <a:defRPr/>
             </a:lvl6pPr>
             <a:lvl7pPr marL="0" indent="0">
               <a:lnSpc>
@@ -2717,6 +2937,7 @@
                 <a:spcPts val="0"/>
               </a:spcAft>
               <a:buNone/>
+              <a:defRPr/>
             </a:lvl7pPr>
             <a:lvl8pPr marL="0" indent="0">
               <a:lnSpc>
@@ -2729,6 +2950,7 @@
                 <a:spcPts val="0"/>
               </a:spcAft>
               <a:buNone/>
+              <a:defRPr/>
             </a:lvl8pPr>
             <a:lvl9pPr marL="0" indent="0">
               <a:lnSpc>
@@ -2741,6 +2963,7 @@
                 <a:spcPts val="0"/>
               </a:spcAft>
               <a:buNone/>
+              <a:defRPr/>
             </a:lvl9pPr>
           </a:lstStyle>
           <a:p xmlns:a="http://schemas.openxmlformats.org/drawingml/2006/main"/>
@@ -2802,6 +3025,7 @@
                 <a:spcPts val="1200"/>
               </a:spcAft>
               <a:buChar char="•"/>
+              <a:defRPr/>
             </a:lvl1pPr>
             <a:lvl2pPr marL="533400" indent="-228600">
               <a:lnSpc>
@@ -2814,6 +3038,7 @@
                 <a:spcPts val="1200"/>
               </a:spcAft>
               <a:buChar char="•"/>
+              <a:defRPr/>
             </a:lvl2pPr>
             <a:lvl3pPr marL="838200" indent="-228600">
               <a:lnSpc>
@@ -2826,6 +3051,7 @@
                 <a:spcPts val="1200"/>
               </a:spcAft>
               <a:buChar char="•"/>
+              <a:defRPr/>
             </a:lvl3pPr>
             <a:lvl4pPr marL="1143000" indent="-228600">
               <a:lnSpc>
@@ -2838,6 +3064,7 @@
                 <a:spcPts val="1200"/>
               </a:spcAft>
               <a:buChar char="•"/>
+              <a:defRPr/>
             </a:lvl4pPr>
             <a:lvl5pPr marL="1447800" indent="-228600">
               <a:lnSpc>
@@ -2850,6 +3077,7 @@
                 <a:spcPts val="1200"/>
               </a:spcAft>
               <a:buChar char="•"/>
+              <a:defRPr/>
             </a:lvl5pPr>
             <a:lvl6pPr marL="1752600" indent="-228600">
               <a:lnSpc>
@@ -2862,6 +3090,7 @@
                 <a:spcPts val="1200"/>
               </a:spcAft>
               <a:buChar char="•"/>
+              <a:defRPr/>
             </a:lvl6pPr>
             <a:lvl7pPr marL="2057400" indent="-228600">
               <a:lnSpc>
@@ -2874,6 +3103,7 @@
                 <a:spcPts val="1200"/>
               </a:spcAft>
               <a:buChar char="•"/>
+              <a:defRPr/>
             </a:lvl7pPr>
             <a:lvl8pPr marL="2362200" indent="-228600">
               <a:lnSpc>
@@ -2886,6 +3116,7 @@
                 <a:spcPts val="1200"/>
               </a:spcAft>
               <a:buChar char="•"/>
+              <a:defRPr/>
             </a:lvl8pPr>
             <a:lvl9pPr marL="2667000" indent="-228600">
               <a:lnSpc>
@@ -2898,6 +3129,7 @@
                 <a:spcPts val="1200"/>
               </a:spcAft>
               <a:buChar char="•"/>
+              <a:defRPr/>
             </a:lvl9pPr>
           </a:lstStyle>
           <a:p xmlns:a="http://schemas.openxmlformats.org/drawingml/2006/main"/>
@@ -2946,12 +3178,12 @@
   </p:cSld>
   <p:clrMap bg1="lt1" tx1="dk1" bg2="lt2" tx2="dk2" accent1="accent1" accent2="accent2" accent3="accent3" accent4="accent4" accent5="accent5" accent6="accent6" hlink="hlink" folHlink="folHlink"/>
   <p:sldLayoutIdLst>
-    <p:sldLayoutId xmlns:r="http://schemas.openxmlformats.org/officeDocument/2006/relationships" id="2147483649" r:id="R84e9d626cece47e6"/>
-    <p:sldLayoutId xmlns:r="http://schemas.openxmlformats.org/officeDocument/2006/relationships" id="2147483650" r:id="R78ffa95af9d84772"/>
-    <p:sldLayoutId xmlns:r="http://schemas.openxmlformats.org/officeDocument/2006/relationships" id="2147483651" r:id="Rf706e31a3dd54426"/>
-    <p:sldLayoutId xmlns:r="http://schemas.openxmlformats.org/officeDocument/2006/relationships" id="2147483652" r:id="Re261fccd202e4b87"/>
-    <p:sldLayoutId xmlns:r="http://schemas.openxmlformats.org/officeDocument/2006/relationships" id="2147483653" r:id="R35b0151c38274f87"/>
-    <p:sldLayoutId xmlns:r="http://schemas.openxmlformats.org/officeDocument/2006/relationships" id="2147483654" r:id="R4c72599fc4be4444"/>
+    <p:sldLayoutId xmlns:r="http://schemas.openxmlformats.org/officeDocument/2006/relationships" id="2147483649" r:id="R9d3718081f5b4fad"/>
+    <p:sldLayoutId xmlns:r="http://schemas.openxmlformats.org/officeDocument/2006/relationships" id="2147483650" r:id="R5783585c45d64bdd"/>
+    <p:sldLayoutId xmlns:r="http://schemas.openxmlformats.org/officeDocument/2006/relationships" id="2147483651" r:id="R3159d9b96cbd4472"/>
+    <p:sldLayoutId xmlns:r="http://schemas.openxmlformats.org/officeDocument/2006/relationships" id="2147483652" r:id="R13ce832c776e49ff"/>
+    <p:sldLayoutId xmlns:r="http://schemas.openxmlformats.org/officeDocument/2006/relationships" id="2147483653" r:id="R6c94290cf3154959"/>
+    <p:sldLayoutId xmlns:r="http://schemas.openxmlformats.org/officeDocument/2006/relationships" id="2147483654" r:id="Rfb43ff429bc341f6"/>
   </p:sldLayoutIdLst>
   <p:txStyles>
     <p:titleStyle>
@@ -3540,6 +3772,7 @@
           </a:lstStyle>
           <a:p xmlns:a="http://schemas.openxmlformats.org/drawingml/2006/main">
             <a:pPr>
+              <a:buNone/>
               <a:defRPr sz="4275" b="1">
                 <a:solidFill>
                   <a:srgbClr val="FFFFFF"/>
@@ -3563,6 +3796,7 @@
           </a:p>
           <a:p xmlns:a="http://schemas.openxmlformats.org/drawingml/2006/main">
             <a:pPr>
+              <a:buNone/>
               <a:defRPr sz="4275" b="1">
                 <a:solidFill>
                   <a:srgbClr val="FFFFFF"/>
@@ -3586,6 +3820,7 @@
           </a:p>
           <a:p xmlns:a="http://schemas.openxmlformats.org/drawingml/2006/main">
             <a:pPr>
+              <a:buNone/>
               <a:defRPr sz="4275" b="1">
                 <a:solidFill>
                   <a:srgbClr val="FFFFFF"/>
@@ -3652,6 +3887,7 @@
           </a:lstStyle>
           <a:p xmlns:a="http://schemas.openxmlformats.org/drawingml/2006/main">
             <a:pPr>
+              <a:buNone/>
               <a:defRPr sz="2100" b="0">
                 <a:solidFill>
                   <a:srgbClr val="A8D8FF"/>
@@ -3718,6 +3954,7 @@
           </a:lstStyle>
           <a:p xmlns:a="http://schemas.openxmlformats.org/drawingml/2006/main">
             <a:pPr>
+              <a:buNone/>
               <a:defRPr sz="1725" b="0">
                 <a:solidFill>
                   <a:srgbClr val="FFFFFF"/>
@@ -3736,7 +3973,7 @@
                 <a:ea typeface="DejaVu Sans"/>
                 <a:cs typeface="DejaVu Sans"/>
               </a:rPr>
-              <a:t>Hamza Rasheed   Muhammad Danial   Muhammad Freeh</a:t>
+              <a:t>Muhammad Danial   Hamza Rasheed   Muhammad Freeh</a:t>
             </a:r>
           </a:p>
         </p:txBody>
@@ -3784,6 +4021,7 @@
           </a:lstStyle>
           <a:p xmlns:a="http://schemas.openxmlformats.org/drawingml/2006/main">
             <a:pPr>
+              <a:buNone/>
               <a:defRPr sz="1650" b="0">
                 <a:solidFill>
                   <a:srgbClr val="A8D8FF"/>
@@ -3802,7 +4040,7 @@
                 <a:ea typeface="DejaVu Sans"/>
                 <a:cs typeface="DejaVu Sans"/>
               </a:rPr>
-              <a:t>Research demonstration with prepared features</a:t>
+              <a:t>Prepared-feature research and AV-ASD MP4 analysis</a:t>
             </a:r>
           </a:p>
         </p:txBody>
@@ -3879,6 +4117,7 @@
           </a:lstStyle>
           <a:p xmlns:a="http://schemas.openxmlformats.org/drawingml/2006/main">
             <a:pPr>
+              <a:buNone/>
               <a:defRPr sz="3000" b="1">
                 <a:solidFill>
                   <a:srgbClr val="102A43"/>
@@ -3945,6 +4184,7 @@
           </a:lstStyle>
           <a:p xmlns:a="http://schemas.openxmlformats.org/drawingml/2006/main">
             <a:pPr>
+              <a:buNone/>
               <a:defRPr sz="1200" b="0">
                 <a:solidFill>
                   <a:srgbClr val="627D98"/>
@@ -4011,6 +4251,7 @@
           </a:lstStyle>
           <a:p xmlns:a="http://schemas.openxmlformats.org/drawingml/2006/main">
             <a:pPr>
+              <a:buNone/>
               <a:defRPr sz="2025" b="0">
                 <a:solidFill>
                   <a:srgbClr val="17324D"/>
@@ -4077,6 +4318,7 @@
           </a:lstStyle>
           <a:p xmlns:a="http://schemas.openxmlformats.org/drawingml/2006/main">
             <a:pPr>
+              <a:buNone/>
               <a:defRPr sz="2025" b="0">
                 <a:solidFill>
                   <a:srgbClr val="17324D"/>
@@ -4143,6 +4385,7 @@
           </a:lstStyle>
           <a:p xmlns:a="http://schemas.openxmlformats.org/drawingml/2006/main">
             <a:pPr>
+              <a:buNone/>
               <a:defRPr sz="2025" b="0">
                 <a:solidFill>
                   <a:srgbClr val="17324D"/>
@@ -4209,6 +4452,7 @@
           </a:lstStyle>
           <a:p xmlns:a="http://schemas.openxmlformats.org/drawingml/2006/main">
             <a:pPr>
+              <a:buNone/>
               <a:defRPr sz="2025" b="0">
                 <a:solidFill>
                   <a:srgbClr val="17324D"/>
@@ -4275,6 +4519,7 @@
           </a:lstStyle>
           <a:p xmlns:a="http://schemas.openxmlformats.org/drawingml/2006/main">
             <a:pPr>
+              <a:buNone/>
               <a:defRPr sz="2025" b="0">
                 <a:solidFill>
                   <a:srgbClr val="17324D"/>
@@ -4370,6 +4615,7 @@
           </a:lstStyle>
           <a:p xmlns:a="http://schemas.openxmlformats.org/drawingml/2006/main">
             <a:pPr>
+              <a:buNone/>
               <a:defRPr sz="3000" b="1">
                 <a:solidFill>
                   <a:srgbClr val="102A43"/>
@@ -4388,7 +4634,7 @@
                 <a:ea typeface="DejaVu Sans"/>
                 <a:cs typeface="DejaVu Sans"/>
               </a:rPr>
-              <a:t>Dashboard demonstration</a:t>
+              <a:t>ASD-FEAT feature demonstration</a:t>
             </a:r>
           </a:p>
         </p:txBody>
@@ -4436,6 +4682,7 @@
           </a:lstStyle>
           <a:p xmlns:a="http://schemas.openxmlformats.org/drawingml/2006/main">
             <a:pPr>
+              <a:buNone/>
               <a:defRPr sz="1200" b="0">
                 <a:solidFill>
                   <a:srgbClr val="627D98"/>
@@ -4502,6 +4749,7 @@
           </a:lstStyle>
           <a:p xmlns:a="http://schemas.openxmlformats.org/drawingml/2006/main">
             <a:pPr>
+              <a:buNone/>
               <a:defRPr sz="2025" b="0">
                 <a:solidFill>
                   <a:srgbClr val="17324D"/>
@@ -4568,6 +4816,7 @@
           </a:lstStyle>
           <a:p xmlns:a="http://schemas.openxmlformats.org/drawingml/2006/main">
             <a:pPr>
+              <a:buNone/>
               <a:defRPr sz="2025" b="0">
                 <a:solidFill>
                   <a:srgbClr val="17324D"/>
@@ -4634,6 +4883,7 @@
           </a:lstStyle>
           <a:p xmlns:a="http://schemas.openxmlformats.org/drawingml/2006/main">
             <a:pPr>
+              <a:buNone/>
               <a:defRPr sz="2025" b="0">
                 <a:solidFill>
                   <a:srgbClr val="17324D"/>
@@ -4700,6 +4950,7 @@
           </a:lstStyle>
           <a:p xmlns:a="http://schemas.openxmlformats.org/drawingml/2006/main">
             <a:pPr>
+              <a:buNone/>
               <a:defRPr sz="2025" b="0">
                 <a:solidFill>
                   <a:srgbClr val="17324D"/>
@@ -4766,6 +5017,7 @@
           </a:lstStyle>
           <a:p xmlns:a="http://schemas.openxmlformats.org/drawingml/2006/main">
             <a:pPr>
+              <a:buNone/>
               <a:defRPr sz="2025" b="0">
                 <a:solidFill>
                   <a:srgbClr val="17324D"/>
@@ -4832,6 +5084,7 @@
           </a:lstStyle>
           <a:p xmlns:a="http://schemas.openxmlformats.org/drawingml/2006/main">
             <a:pPr>
+              <a:buNone/>
               <a:defRPr sz="1800" b="0">
                 <a:solidFill>
                   <a:srgbClr val="9C2F22"/>
@@ -4927,6 +5180,7 @@
           </a:lstStyle>
           <a:p xmlns:a="http://schemas.openxmlformats.org/drawingml/2006/main">
             <a:pPr>
+              <a:buNone/>
               <a:defRPr sz="3000" b="1">
                 <a:solidFill>
                   <a:srgbClr val="102A43"/>
@@ -4945,7 +5199,7 @@
                 <a:ea typeface="DejaVu Sans"/>
                 <a:cs typeface="DejaVu Sans"/>
               </a:rPr>
-              <a:t>Conclusions and next research steps</a:t>
+              <a:t>AV-ASD video upload</a:t>
             </a:r>
           </a:p>
         </p:txBody>
@@ -4993,6 +5247,7 @@
           </a:lstStyle>
           <a:p xmlns:a="http://schemas.openxmlformats.org/drawingml/2006/main">
             <a:pPr>
+              <a:buNone/>
               <a:defRPr sz="1200" b="0">
                 <a:solidFill>
                   <a:srgbClr val="627D98"/>
@@ -5059,6 +5314,7 @@
           </a:lstStyle>
           <a:p xmlns:a="http://schemas.openxmlformats.org/drawingml/2006/main">
             <a:pPr>
+              <a:buNone/>
               <a:defRPr sz="2025" b="0">
                 <a:solidFill>
                   <a:srgbClr val="17324D"/>
@@ -5077,7 +5333,7 @@
                 <a:ea typeface="DejaVu Sans"/>
                 <a:cs typeface="DejaVu Sans"/>
               </a:rPr>
-              <a:t>RGB plus human-coded behavior leads the tested development F1 comparison</a:t>
+              <a:t>Local MP4 with audio: up to 120 seconds, 7,200 frames and 200 MiB</a:t>
             </a:r>
           </a:p>
         </p:txBody>
@@ -5125,6 +5381,7 @@
           </a:lstStyle>
           <a:p xmlns:a="http://schemas.openxmlformats.org/drawingml/2006/main">
             <a:pPr>
+              <a:buNone/>
               <a:defRPr sz="2025" b="0">
                 <a:solidFill>
                   <a:srgbClr val="17324D"/>
@@ -5143,7 +5400,7 @@
                 <a:ea typeface="DejaVu Sans"/>
                 <a:cs typeface="DejaVu Sans"/>
               </a:rPr>
-              <a:t>Low precision and one positive test participant limit generalization</a:t>
+              <a:t>Frozen combined LR: 44 audio + 14 visual features; threshold 0.30</a:t>
             </a:r>
           </a:p>
         </p:txBody>
@@ -5191,6 +5448,7 @@
           </a:lstStyle>
           <a:p xmlns:a="http://schemas.openxmlformats.org/drawingml/2006/main">
             <a:pPr>
+              <a:buNone/>
               <a:defRPr sz="2025" b="0">
                 <a:solidFill>
                   <a:srgbClr val="17324D"/>
@@ -5209,7 +5467,7 @@
                 <a:ea typeface="DejaVu Sans"/>
                 <a:cs typeface="DejaVu Sans"/>
               </a:rPr>
-              <a:t>The prototype accepts compatible features and exports fitted-score explanations</a:t>
+              <a:t>Ten label scores, recording summary and top feature contributions</a:t>
             </a:r>
           </a:p>
         </p:txBody>
@@ -5257,6 +5515,7 @@
           </a:lstStyle>
           <a:p xmlns:a="http://schemas.openxmlformats.org/drawingml/2006/main">
             <a:pPr>
+              <a:buNone/>
               <a:defRPr sz="2025" b="0">
                 <a:solidFill>
                   <a:srgbClr val="17324D"/>
@@ -5275,7 +5534,7 @@
                 <a:ea typeface="DejaVu Sans"/>
                 <a:cs typeface="DejaVu Sans"/>
               </a:rPr>
-              <a:t>Independent participant validation and provenance verification remain necessary</a:t>
+              <a:t>Silent audio flagged; no-audio, long and corrupt inputs rejected</a:t>
             </a:r>
           </a:p>
         </p:txBody>
@@ -5323,6 +5582,7 @@
           </a:lstStyle>
           <a:p xmlns:a="http://schemas.openxmlformats.org/drawingml/2006/main">
             <a:pPr>
+              <a:buNone/>
               <a:defRPr sz="2025" b="0">
                 <a:solidFill>
                   <a:srgbClr val="17324D"/>
@@ -5341,7 +5601,7 @@
                 <a:ea typeface="DejaVu Sans"/>
                 <a:cs typeface="DejaVu Sans"/>
               </a:rPr>
-              <a:t>Raw-media extraction and temporal modeling remain future research</a:t>
+              <a:t>HTML/JSON export; selecting another video clears the previous report</a:t>
             </a:r>
           </a:p>
         </p:txBody>
@@ -5350,6 +5610,1002 @@
     <p:extLst>
       <p:ext uri="{BB962C8B-B14F-4D97-AF65-F5344CB8AC3E}">
         <p14:creationId xmlns:p14="http://schemas.microsoft.com/office/powerpoint/2010/main" val="910301582"/>
+      </p:ext>
+    </p:extLst>
+  </p:cSld>
+</p:sld>
+</file>
+
+<file path=ppt/slides/slide13.xml><?xml version="1.0" encoding="utf-8"?>
+<p:sld xmlns:p="http://schemas.openxmlformats.org/presentationml/2006/main">
+  <p:cSld>
+    <p:bg>
+      <p:bgPr>
+        <a:solidFill xmlns:a="http://schemas.openxmlformats.org/drawingml/2006/main">
+          <a:srgbClr val="FFFFFF"/>
+        </a:solidFill>
+      </p:bgPr>
+    </p:bg>
+    <p:spTree>
+      <p:nvGrpSpPr>
+        <p:cNvPr id="1" name=""/>
+        <p:cNvGrpSpPr/>
+        <p:nvPr/>
+      </p:nvGrpSpPr>
+      <p:grpSpPr>
+        <a:xfrm xmlns:a="http://schemas.openxmlformats.org/drawingml/2006/main"/>
+      </p:grpSpPr>
+      <p:sp>
+        <p:nvSpPr>
+          <p:cNvPr id="8" name="">
+            <a:extLst xmlns:a="http://schemas.openxmlformats.org/drawingml/2006/main">
+              <a:ext uri="{FF2B5EF4-FFF2-40B4-BE49-F238E27FC236}">
+                <a16:creationId xmlns:a16="http://schemas.microsoft.com/office/drawing/2014/main" id="{22B19141-1D52-4C39-B61A-D47FA966A6EA}"/>
+              </a:ext>
+            </a:extLst>
+          </p:cNvPr>
+          <p:cNvSpPr>
+            <a:spLocks xmlns:a="http://schemas.openxmlformats.org/drawingml/2006/main" noGrp="1"/>
+          </p:cNvSpPr>
+          <p:nvPr/>
+        </p:nvSpPr>
+        <p:spPr>
+          <a:xfrm xmlns:a="http://schemas.openxmlformats.org/drawingml/2006/main">
+            <a:off x="619125" y="457200"/>
+            <a:ext cx="10858500" cy="904875"/>
+          </a:xfrm>
+          <a:prstGeom xmlns:a="http://schemas.openxmlformats.org/drawingml/2006/main" prst="rect">
+            <a:avLst/>
+          </a:prstGeom>
+          <a:noFill xmlns:a="http://schemas.openxmlformats.org/drawingml/2006/main"/>
+          <a:ln xmlns:a="http://schemas.openxmlformats.org/drawingml/2006/main" w="0">
+            <a:noFill/>
+          </a:ln>
+        </p:spPr>
+        <p:txBody>
+          <a:bodyPr xmlns:a="http://schemas.openxmlformats.org/drawingml/2006/main"/>
+          <a:lstStyle xmlns:a="http://schemas.openxmlformats.org/drawingml/2006/main">
+            <a:defPPr>
+              <a:defRPr sz="3000" b="1">
+                <a:solidFill>
+                  <a:srgbClr val="102A43"/>
+                </a:solidFill>
+                <a:latin typeface="DejaVu Sans"/>
+                <a:ea typeface="DejaVu Sans"/>
+                <a:cs typeface="DejaVu Sans"/>
+              </a:defRPr>
+            </a:defPPr>
+          </a:lstStyle>
+          <a:p xmlns:a="http://schemas.openxmlformats.org/drawingml/2006/main">
+            <a:pPr>
+              <a:buNone/>
+              <a:defRPr sz="3000" b="1">
+                <a:solidFill>
+                  <a:srgbClr val="102A43"/>
+                </a:solidFill>
+                <a:latin typeface="DejaVu Sans"/>
+                <a:ea typeface="DejaVu Sans"/>
+                <a:cs typeface="DejaVu Sans"/>
+              </a:defRPr>
+            </a:pPr>
+            <a:r>
+              <a:rPr sz="3000" b="1">
+                <a:solidFill>
+                  <a:srgbClr val="102A43"/>
+                </a:solidFill>
+                <a:latin typeface="DejaVu Sans"/>
+                <a:ea typeface="DejaVu Sans"/>
+                <a:cs typeface="DejaVu Sans"/>
+              </a:rPr>
+              <a:t>Video workflow validation</a:t>
+            </a:r>
+          </a:p>
+        </p:txBody>
+      </p:sp>
+      <p:sp>
+        <p:nvSpPr>
+          <p:cNvPr id="2" name="">
+            <a:extLst xmlns:a="http://schemas.openxmlformats.org/drawingml/2006/main">
+              <a:ext uri="{FF2B5EF4-FFF2-40B4-BE49-F238E27FC236}">
+                <a16:creationId xmlns:a16="http://schemas.microsoft.com/office/drawing/2014/main" id="{E56CFFB7-ECFB-4619-8CCC-51A84B52AA23}"/>
+              </a:ext>
+            </a:extLst>
+          </p:cNvPr>
+          <p:cNvSpPr>
+            <a:spLocks xmlns:a="http://schemas.openxmlformats.org/drawingml/2006/main" noGrp="1"/>
+          </p:cNvSpPr>
+          <p:nvPr/>
+        </p:nvSpPr>
+        <p:spPr>
+          <a:xfrm xmlns:a="http://schemas.openxmlformats.org/drawingml/2006/main">
+            <a:off x="11144250" y="6334125"/>
+            <a:ext cx="476250" cy="266700"/>
+          </a:xfrm>
+          <a:prstGeom xmlns:a="http://schemas.openxmlformats.org/drawingml/2006/main" prst="rect">
+            <a:avLst/>
+          </a:prstGeom>
+          <a:noFill xmlns:a="http://schemas.openxmlformats.org/drawingml/2006/main"/>
+          <a:ln xmlns:a="http://schemas.openxmlformats.org/drawingml/2006/main" w="0">
+            <a:noFill/>
+          </a:ln>
+        </p:spPr>
+        <p:txBody>
+          <a:bodyPr xmlns:a="http://schemas.openxmlformats.org/drawingml/2006/main"/>
+          <a:lstStyle xmlns:a="http://schemas.openxmlformats.org/drawingml/2006/main">
+            <a:defPPr>
+              <a:defRPr sz="1200" b="0">
+                <a:solidFill>
+                  <a:srgbClr val="627D98"/>
+                </a:solidFill>
+                <a:latin typeface="DejaVu Sans"/>
+                <a:ea typeface="DejaVu Sans"/>
+                <a:cs typeface="DejaVu Sans"/>
+              </a:defRPr>
+            </a:defPPr>
+          </a:lstStyle>
+          <a:p xmlns:a="http://schemas.openxmlformats.org/drawingml/2006/main">
+            <a:pPr>
+              <a:buNone/>
+              <a:defRPr sz="1200" b="0">
+                <a:solidFill>
+                  <a:srgbClr val="627D98"/>
+                </a:solidFill>
+                <a:latin typeface="DejaVu Sans"/>
+                <a:ea typeface="DejaVu Sans"/>
+                <a:cs typeface="DejaVu Sans"/>
+              </a:defRPr>
+            </a:pPr>
+            <a:r>
+              <a:rPr sz="1200" b="0">
+                <a:solidFill>
+                  <a:srgbClr val="627D98"/>
+                </a:solidFill>
+                <a:latin typeface="DejaVu Sans"/>
+                <a:ea typeface="DejaVu Sans"/>
+                <a:cs typeface="DejaVu Sans"/>
+              </a:rPr>
+              <a:t>13</a:t>
+            </a:r>
+          </a:p>
+        </p:txBody>
+      </p:sp>
+      <p:sp>
+        <p:nvSpPr>
+          <p:cNvPr id="3" name="">
+            <a:extLst xmlns:a="http://schemas.openxmlformats.org/drawingml/2006/main">
+              <a:ext uri="{FF2B5EF4-FFF2-40B4-BE49-F238E27FC236}">
+                <a16:creationId xmlns:a16="http://schemas.microsoft.com/office/drawing/2014/main" id="{90117982-440C-4D15-A3CB-46528699321B}"/>
+              </a:ext>
+            </a:extLst>
+          </p:cNvPr>
+          <p:cNvSpPr>
+            <a:spLocks xmlns:a="http://schemas.openxmlformats.org/drawingml/2006/main" noGrp="1"/>
+          </p:cNvSpPr>
+          <p:nvPr/>
+        </p:nvSpPr>
+        <p:spPr>
+          <a:xfrm xmlns:a="http://schemas.openxmlformats.org/drawingml/2006/main">
+            <a:off x="714375" y="1657350"/>
+            <a:ext cx="10572750" cy="742950"/>
+          </a:xfrm>
+          <a:prstGeom xmlns:a="http://schemas.openxmlformats.org/drawingml/2006/main" prst="rect">
+            <a:avLst/>
+          </a:prstGeom>
+          <a:noFill xmlns:a="http://schemas.openxmlformats.org/drawingml/2006/main"/>
+          <a:ln xmlns:a="http://schemas.openxmlformats.org/drawingml/2006/main" w="0">
+            <a:noFill/>
+          </a:ln>
+        </p:spPr>
+        <p:txBody>
+          <a:bodyPr xmlns:a="http://schemas.openxmlformats.org/drawingml/2006/main"/>
+          <a:lstStyle xmlns:a="http://schemas.openxmlformats.org/drawingml/2006/main">
+            <a:defPPr>
+              <a:defRPr sz="2025" b="0">
+                <a:solidFill>
+                  <a:srgbClr val="17324D"/>
+                </a:solidFill>
+                <a:latin typeface="DejaVu Sans"/>
+                <a:ea typeface="DejaVu Sans"/>
+                <a:cs typeface="DejaVu Sans"/>
+              </a:defRPr>
+            </a:defPPr>
+          </a:lstStyle>
+          <a:p xmlns:a="http://schemas.openxmlformats.org/drawingml/2006/main">
+            <a:pPr>
+              <a:buNone/>
+              <a:defRPr sz="2025" b="0">
+                <a:solidFill>
+                  <a:srgbClr val="17324D"/>
+                </a:solidFill>
+                <a:latin typeface="DejaVu Sans"/>
+                <a:ea typeface="DejaVu Sans"/>
+                <a:cs typeface="DejaVu Sans"/>
+              </a:defRPr>
+            </a:pPr>
+            <a:r>
+              <a:rPr sz="2025" b="0">
+                <a:solidFill>
+                  <a:srgbClr val="17324D"/>
+                </a:solidFill>
+                <a:latin typeface="DejaVu Sans"/>
+                <a:ea typeface="DejaVu Sans"/>
+                <a:cs typeface="DejaVu Sans"/>
+              </a:rPr>
+              <a:t>5 / 5 existing clips reproduced saved features and predictions</a:t>
+            </a:r>
+          </a:p>
+        </p:txBody>
+      </p:sp>
+      <p:sp>
+        <p:nvSpPr>
+          <p:cNvPr id="4" name="">
+            <a:extLst xmlns:a="http://schemas.openxmlformats.org/drawingml/2006/main">
+              <a:ext uri="{FF2B5EF4-FFF2-40B4-BE49-F238E27FC236}">
+                <a16:creationId xmlns:a16="http://schemas.microsoft.com/office/drawing/2014/main" id="{ED26DBEC-09F7-48FF-AD38-B3D7D278FBDD}"/>
+              </a:ext>
+            </a:extLst>
+          </p:cNvPr>
+          <p:cNvSpPr>
+            <a:spLocks xmlns:a="http://schemas.openxmlformats.org/drawingml/2006/main" noGrp="1"/>
+          </p:cNvSpPr>
+          <p:nvPr/>
+        </p:nvSpPr>
+        <p:spPr>
+          <a:xfrm xmlns:a="http://schemas.openxmlformats.org/drawingml/2006/main">
+            <a:off x="714375" y="2505075"/>
+            <a:ext cx="10572750" cy="742950"/>
+          </a:xfrm>
+          <a:prstGeom xmlns:a="http://schemas.openxmlformats.org/drawingml/2006/main" prst="rect">
+            <a:avLst/>
+          </a:prstGeom>
+          <a:noFill xmlns:a="http://schemas.openxmlformats.org/drawingml/2006/main"/>
+          <a:ln xmlns:a="http://schemas.openxmlformats.org/drawingml/2006/main" w="0">
+            <a:noFill/>
+          </a:ln>
+        </p:spPr>
+        <p:txBody>
+          <a:bodyPr xmlns:a="http://schemas.openxmlformats.org/drawingml/2006/main"/>
+          <a:lstStyle xmlns:a="http://schemas.openxmlformats.org/drawingml/2006/main">
+            <a:defPPr>
+              <a:defRPr sz="2025" b="0">
+                <a:solidFill>
+                  <a:srgbClr val="17324D"/>
+                </a:solidFill>
+                <a:latin typeface="DejaVu Sans"/>
+                <a:ea typeface="DejaVu Sans"/>
+                <a:cs typeface="DejaVu Sans"/>
+              </a:defRPr>
+            </a:defPPr>
+          </a:lstStyle>
+          <a:p xmlns:a="http://schemas.openxmlformats.org/drawingml/2006/main">
+            <a:pPr>
+              <a:buNone/>
+              <a:defRPr sz="2025" b="0">
+                <a:solidFill>
+                  <a:srgbClr val="17324D"/>
+                </a:solidFill>
+                <a:latin typeface="DejaVu Sans"/>
+                <a:ea typeface="DejaVu Sans"/>
+                <a:cs typeface="DejaVu Sans"/>
+              </a:defRPr>
+            </a:pPr>
+            <a:r>
+              <a:rPr sz="2025" b="0">
+                <a:solidFill>
+                  <a:srgbClr val="17324D"/>
+                </a:solidFill>
+                <a:latin typeface="DejaVu Sans"/>
+                <a:ea typeface="DejaVu Sans"/>
+                <a:cs typeface="DejaVu Sans"/>
+              </a:rPr>
+              <a:t>5 / 5 synthetic upload cases passed acceptance and rejection checks</a:t>
+            </a:r>
+          </a:p>
+        </p:txBody>
+      </p:sp>
+      <p:sp>
+        <p:nvSpPr>
+          <p:cNvPr id="5" name="">
+            <a:extLst xmlns:a="http://schemas.openxmlformats.org/drawingml/2006/main">
+              <a:ext uri="{FF2B5EF4-FFF2-40B4-BE49-F238E27FC236}">
+                <a16:creationId xmlns:a16="http://schemas.microsoft.com/office/drawing/2014/main" id="{2891D931-9969-4670-8985-7BDE5B75B6F5}"/>
+              </a:ext>
+            </a:extLst>
+          </p:cNvPr>
+          <p:cNvSpPr>
+            <a:spLocks xmlns:a="http://schemas.openxmlformats.org/drawingml/2006/main" noGrp="1"/>
+          </p:cNvSpPr>
+          <p:nvPr/>
+        </p:nvSpPr>
+        <p:spPr>
+          <a:xfrm xmlns:a="http://schemas.openxmlformats.org/drawingml/2006/main">
+            <a:off x="714375" y="3352800"/>
+            <a:ext cx="10572750" cy="742950"/>
+          </a:xfrm>
+          <a:prstGeom xmlns:a="http://schemas.openxmlformats.org/drawingml/2006/main" prst="rect">
+            <a:avLst/>
+          </a:prstGeom>
+          <a:noFill xmlns:a="http://schemas.openxmlformats.org/drawingml/2006/main"/>
+          <a:ln xmlns:a="http://schemas.openxmlformats.org/drawingml/2006/main" w="0">
+            <a:noFill/>
+          </a:ln>
+        </p:spPr>
+        <p:txBody>
+          <a:bodyPr xmlns:a="http://schemas.openxmlformats.org/drawingml/2006/main"/>
+          <a:lstStyle xmlns:a="http://schemas.openxmlformats.org/drawingml/2006/main">
+            <a:defPPr>
+              <a:defRPr sz="2025" b="0">
+                <a:solidFill>
+                  <a:srgbClr val="17324D"/>
+                </a:solidFill>
+                <a:latin typeface="DejaVu Sans"/>
+                <a:ea typeface="DejaVu Sans"/>
+                <a:cs typeface="DejaVu Sans"/>
+              </a:defRPr>
+            </a:defPPr>
+          </a:lstStyle>
+          <a:p xmlns:a="http://schemas.openxmlformats.org/drawingml/2006/main">
+            <a:pPr>
+              <a:buNone/>
+              <a:defRPr sz="2025" b="0">
+                <a:solidFill>
+                  <a:srgbClr val="17324D"/>
+                </a:solidFill>
+                <a:latin typeface="DejaVu Sans"/>
+                <a:ea typeface="DejaVu Sans"/>
+                <a:cs typeface="DejaVu Sans"/>
+              </a:defRPr>
+            </a:pPr>
+            <a:r>
+              <a:rPr sz="2025" b="0">
+                <a:solidFill>
+                  <a:srgbClr val="17324D"/>
+                </a:solidFill>
+                <a:latin typeface="DejaVu Sans"/>
+                <a:ea typeface="DejaVu Sans"/>
+                <a:cs typeface="DejaVu Sans"/>
+              </a:rPr>
+              <a:t>1,070 label explanations reconstructed scores across 107 recordings</a:t>
+            </a:r>
+          </a:p>
+        </p:txBody>
+      </p:sp>
+      <p:sp>
+        <p:nvSpPr>
+          <p:cNvPr id="6" name="">
+            <a:extLst xmlns:a="http://schemas.openxmlformats.org/drawingml/2006/main">
+              <a:ext uri="{FF2B5EF4-FFF2-40B4-BE49-F238E27FC236}">
+                <a16:creationId xmlns:a16="http://schemas.microsoft.com/office/drawing/2014/main" id="{6AFD87F7-4C7B-4316-9A70-B710B076F382}"/>
+              </a:ext>
+            </a:extLst>
+          </p:cNvPr>
+          <p:cNvSpPr>
+            <a:spLocks xmlns:a="http://schemas.openxmlformats.org/drawingml/2006/main" noGrp="1"/>
+          </p:cNvSpPr>
+          <p:nvPr/>
+        </p:nvSpPr>
+        <p:spPr>
+          <a:xfrm xmlns:a="http://schemas.openxmlformats.org/drawingml/2006/main">
+            <a:off x="714375" y="4200525"/>
+            <a:ext cx="10572750" cy="742950"/>
+          </a:xfrm>
+          <a:prstGeom xmlns:a="http://schemas.openxmlformats.org/drawingml/2006/main" prst="rect">
+            <a:avLst/>
+          </a:prstGeom>
+          <a:noFill xmlns:a="http://schemas.openxmlformats.org/drawingml/2006/main"/>
+          <a:ln xmlns:a="http://schemas.openxmlformats.org/drawingml/2006/main" w="0">
+            <a:noFill/>
+          </a:ln>
+        </p:spPr>
+        <p:txBody>
+          <a:bodyPr xmlns:a="http://schemas.openxmlformats.org/drawingml/2006/main"/>
+          <a:lstStyle xmlns:a="http://schemas.openxmlformats.org/drawingml/2006/main">
+            <a:defPPr>
+              <a:defRPr sz="2025" b="0">
+                <a:solidFill>
+                  <a:srgbClr val="17324D"/>
+                </a:solidFill>
+                <a:latin typeface="DejaVu Sans"/>
+                <a:ea typeface="DejaVu Sans"/>
+                <a:cs typeface="DejaVu Sans"/>
+              </a:defRPr>
+            </a:defPPr>
+          </a:lstStyle>
+          <a:p xmlns:a="http://schemas.openxmlformats.org/drawingml/2006/main">
+            <a:pPr>
+              <a:buNone/>
+              <a:defRPr sz="2025" b="0">
+                <a:solidFill>
+                  <a:srgbClr val="17324D"/>
+                </a:solidFill>
+                <a:latin typeface="DejaVu Sans"/>
+                <a:ea typeface="DejaVu Sans"/>
+                <a:cs typeface="DejaVu Sans"/>
+              </a:defRPr>
+            </a:pPr>
+            <a:r>
+              <a:rPr sz="2025" b="0">
+                <a:solidFill>
+                  <a:srgbClr val="17324D"/>
+                </a:solidFill>
+                <a:latin typeface="DejaVu Sans"/>
+                <a:ea typeface="DejaVu Sans"/>
+                <a:cs typeface="DejaVu Sans"/>
+              </a:rPr>
+              <a:t>Maximum score difference: 6.66e-16; exported branch sums checked</a:t>
+            </a:r>
+          </a:p>
+        </p:txBody>
+      </p:sp>
+      <p:sp>
+        <p:nvSpPr>
+          <p:cNvPr id="7" name="">
+            <a:extLst xmlns:a="http://schemas.openxmlformats.org/drawingml/2006/main">
+              <a:ext uri="{FF2B5EF4-FFF2-40B4-BE49-F238E27FC236}">
+                <a16:creationId xmlns:a16="http://schemas.microsoft.com/office/drawing/2014/main" id="{7A9816B6-F3E8-448E-A5E7-FA73E4A8C9D5}"/>
+              </a:ext>
+            </a:extLst>
+          </p:cNvPr>
+          <p:cNvSpPr>
+            <a:spLocks xmlns:a="http://schemas.openxmlformats.org/drawingml/2006/main" noGrp="1"/>
+          </p:cNvSpPr>
+          <p:nvPr/>
+        </p:nvSpPr>
+        <p:spPr>
+          <a:xfrm xmlns:a="http://schemas.openxmlformats.org/drawingml/2006/main">
+            <a:off x="714375" y="5048250"/>
+            <a:ext cx="10572750" cy="742950"/>
+          </a:xfrm>
+          <a:prstGeom xmlns:a="http://schemas.openxmlformats.org/drawingml/2006/main" prst="rect">
+            <a:avLst/>
+          </a:prstGeom>
+          <a:noFill xmlns:a="http://schemas.openxmlformats.org/drawingml/2006/main"/>
+          <a:ln xmlns:a="http://schemas.openxmlformats.org/drawingml/2006/main" w="0">
+            <a:noFill/>
+          </a:ln>
+        </p:spPr>
+        <p:txBody>
+          <a:bodyPr xmlns:a="http://schemas.openxmlformats.org/drawingml/2006/main"/>
+          <a:lstStyle xmlns:a="http://schemas.openxmlformats.org/drawingml/2006/main">
+            <a:defPPr>
+              <a:defRPr sz="2025" b="0">
+                <a:solidFill>
+                  <a:srgbClr val="17324D"/>
+                </a:solidFill>
+                <a:latin typeface="DejaVu Sans"/>
+                <a:ea typeface="DejaVu Sans"/>
+                <a:cs typeface="DejaVu Sans"/>
+              </a:defRPr>
+            </a:defPPr>
+          </a:lstStyle>
+          <a:p xmlns:a="http://schemas.openxmlformats.org/drawingml/2006/main">
+            <a:pPr>
+              <a:buNone/>
+              <a:defRPr sz="2025" b="0">
+                <a:solidFill>
+                  <a:srgbClr val="17324D"/>
+                </a:solidFill>
+                <a:latin typeface="DejaVu Sans"/>
+                <a:ea typeface="DejaVu Sans"/>
+                <a:cs typeface="DejaVu Sans"/>
+              </a:defRPr>
+            </a:pPr>
+            <a:r>
+              <a:rPr sz="2025" b="0">
+                <a:solidFill>
+                  <a:srgbClr val="17324D"/>
+                </a:solidFill>
+                <a:latin typeface="DejaVu Sans"/>
+                <a:ea typeface="DejaVu Sans"/>
+                <a:cs typeface="DejaVu Sans"/>
+              </a:rPr>
+              <a:t>These checks do not establish accuracy on arbitrary new videos</a:t>
+            </a:r>
+          </a:p>
+        </p:txBody>
+      </p:sp>
+    </p:spTree>
+    <p:extLst>
+      <p:ext uri="{BB962C8B-B14F-4D97-AF65-F5344CB8AC3E}">
+        <p14:creationId xmlns:p14="http://schemas.microsoft.com/office/powerpoint/2010/main" val="1430934265"/>
+      </p:ext>
+    </p:extLst>
+  </p:cSld>
+</p:sld>
+</file>
+
+<file path=ppt/slides/slide14.xml><?xml version="1.0" encoding="utf-8"?>
+<p:sld xmlns:p="http://schemas.openxmlformats.org/presentationml/2006/main">
+  <p:cSld>
+    <p:bg>
+      <p:bgPr>
+        <a:solidFill xmlns:a="http://schemas.openxmlformats.org/drawingml/2006/main">
+          <a:srgbClr val="FFFFFF"/>
+        </a:solidFill>
+      </p:bgPr>
+    </p:bg>
+    <p:spTree>
+      <p:nvGrpSpPr>
+        <p:cNvPr id="1" name=""/>
+        <p:cNvGrpSpPr/>
+        <p:nvPr/>
+      </p:nvGrpSpPr>
+      <p:grpSpPr>
+        <a:xfrm xmlns:a="http://schemas.openxmlformats.org/drawingml/2006/main"/>
+      </p:grpSpPr>
+      <p:sp>
+        <p:nvSpPr>
+          <p:cNvPr id="8" name="">
+            <a:extLst xmlns:a="http://schemas.openxmlformats.org/drawingml/2006/main">
+              <a:ext uri="{FF2B5EF4-FFF2-40B4-BE49-F238E27FC236}">
+                <a16:creationId xmlns:a16="http://schemas.microsoft.com/office/drawing/2014/main" id="{5F45C8E3-9ABE-4281-AC42-310F87B1EA14}"/>
+              </a:ext>
+            </a:extLst>
+          </p:cNvPr>
+          <p:cNvSpPr>
+            <a:spLocks xmlns:a="http://schemas.openxmlformats.org/drawingml/2006/main" noGrp="1"/>
+          </p:cNvSpPr>
+          <p:nvPr/>
+        </p:nvSpPr>
+        <p:spPr>
+          <a:xfrm xmlns:a="http://schemas.openxmlformats.org/drawingml/2006/main">
+            <a:off x="619125" y="457200"/>
+            <a:ext cx="10858500" cy="904875"/>
+          </a:xfrm>
+          <a:prstGeom xmlns:a="http://schemas.openxmlformats.org/drawingml/2006/main" prst="rect">
+            <a:avLst/>
+          </a:prstGeom>
+          <a:noFill xmlns:a="http://schemas.openxmlformats.org/drawingml/2006/main"/>
+          <a:ln xmlns:a="http://schemas.openxmlformats.org/drawingml/2006/main" w="0">
+            <a:noFill/>
+          </a:ln>
+        </p:spPr>
+        <p:txBody>
+          <a:bodyPr xmlns:a="http://schemas.openxmlformats.org/drawingml/2006/main"/>
+          <a:lstStyle xmlns:a="http://schemas.openxmlformats.org/drawingml/2006/main">
+            <a:defPPr>
+              <a:defRPr sz="3000" b="1">
+                <a:solidFill>
+                  <a:srgbClr val="102A43"/>
+                </a:solidFill>
+                <a:latin typeface="DejaVu Sans"/>
+                <a:ea typeface="DejaVu Sans"/>
+                <a:cs typeface="DejaVu Sans"/>
+              </a:defRPr>
+            </a:defPPr>
+          </a:lstStyle>
+          <a:p xmlns:a="http://schemas.openxmlformats.org/drawingml/2006/main">
+            <a:pPr>
+              <a:buNone/>
+              <a:defRPr sz="3000" b="1">
+                <a:solidFill>
+                  <a:srgbClr val="102A43"/>
+                </a:solidFill>
+                <a:latin typeface="DejaVu Sans"/>
+                <a:ea typeface="DejaVu Sans"/>
+                <a:cs typeface="DejaVu Sans"/>
+              </a:defRPr>
+            </a:pPr>
+            <a:r>
+              <a:rPr sz="3000" b="1">
+                <a:solidFill>
+                  <a:srgbClr val="102A43"/>
+                </a:solidFill>
+                <a:latin typeface="DejaVu Sans"/>
+                <a:ea typeface="DejaVu Sans"/>
+                <a:cs typeface="DejaVu Sans"/>
+              </a:rPr>
+              <a:t>Conclusions and next research steps</a:t>
+            </a:r>
+          </a:p>
+        </p:txBody>
+      </p:sp>
+      <p:sp>
+        <p:nvSpPr>
+          <p:cNvPr id="2" name="">
+            <a:extLst xmlns:a="http://schemas.openxmlformats.org/drawingml/2006/main">
+              <a:ext uri="{FF2B5EF4-FFF2-40B4-BE49-F238E27FC236}">
+                <a16:creationId xmlns:a16="http://schemas.microsoft.com/office/drawing/2014/main" id="{EB1125D8-E616-4954-861A-7E5E09A8EAFB}"/>
+              </a:ext>
+            </a:extLst>
+          </p:cNvPr>
+          <p:cNvSpPr>
+            <a:spLocks xmlns:a="http://schemas.openxmlformats.org/drawingml/2006/main" noGrp="1"/>
+          </p:cNvSpPr>
+          <p:nvPr/>
+        </p:nvSpPr>
+        <p:spPr>
+          <a:xfrm xmlns:a="http://schemas.openxmlformats.org/drawingml/2006/main">
+            <a:off x="11144250" y="6334125"/>
+            <a:ext cx="476250" cy="266700"/>
+          </a:xfrm>
+          <a:prstGeom xmlns:a="http://schemas.openxmlformats.org/drawingml/2006/main" prst="rect">
+            <a:avLst/>
+          </a:prstGeom>
+          <a:noFill xmlns:a="http://schemas.openxmlformats.org/drawingml/2006/main"/>
+          <a:ln xmlns:a="http://schemas.openxmlformats.org/drawingml/2006/main" w="0">
+            <a:noFill/>
+          </a:ln>
+        </p:spPr>
+        <p:txBody>
+          <a:bodyPr xmlns:a="http://schemas.openxmlformats.org/drawingml/2006/main"/>
+          <a:lstStyle xmlns:a="http://schemas.openxmlformats.org/drawingml/2006/main">
+            <a:defPPr>
+              <a:defRPr sz="1200" b="0">
+                <a:solidFill>
+                  <a:srgbClr val="627D98"/>
+                </a:solidFill>
+                <a:latin typeface="DejaVu Sans"/>
+                <a:ea typeface="DejaVu Sans"/>
+                <a:cs typeface="DejaVu Sans"/>
+              </a:defRPr>
+            </a:defPPr>
+          </a:lstStyle>
+          <a:p xmlns:a="http://schemas.openxmlformats.org/drawingml/2006/main">
+            <a:pPr>
+              <a:buNone/>
+              <a:defRPr sz="1200" b="0">
+                <a:solidFill>
+                  <a:srgbClr val="627D98"/>
+                </a:solidFill>
+                <a:latin typeface="DejaVu Sans"/>
+                <a:ea typeface="DejaVu Sans"/>
+                <a:cs typeface="DejaVu Sans"/>
+              </a:defRPr>
+            </a:pPr>
+            <a:r>
+              <a:rPr sz="1200" b="0">
+                <a:solidFill>
+                  <a:srgbClr val="627D98"/>
+                </a:solidFill>
+                <a:latin typeface="DejaVu Sans"/>
+                <a:ea typeface="DejaVu Sans"/>
+                <a:cs typeface="DejaVu Sans"/>
+              </a:rPr>
+              <a:t>14</a:t>
+            </a:r>
+          </a:p>
+        </p:txBody>
+      </p:sp>
+      <p:sp>
+        <p:nvSpPr>
+          <p:cNvPr id="3" name="">
+            <a:extLst xmlns:a="http://schemas.openxmlformats.org/drawingml/2006/main">
+              <a:ext uri="{FF2B5EF4-FFF2-40B4-BE49-F238E27FC236}">
+                <a16:creationId xmlns:a16="http://schemas.microsoft.com/office/drawing/2014/main" id="{0BAAD42F-0D9E-45AB-9EF5-EFD25522EAD1}"/>
+              </a:ext>
+            </a:extLst>
+          </p:cNvPr>
+          <p:cNvSpPr>
+            <a:spLocks xmlns:a="http://schemas.openxmlformats.org/drawingml/2006/main" noGrp="1"/>
+          </p:cNvSpPr>
+          <p:nvPr/>
+        </p:nvSpPr>
+        <p:spPr>
+          <a:xfrm xmlns:a="http://schemas.openxmlformats.org/drawingml/2006/main">
+            <a:off x="714375" y="1657350"/>
+            <a:ext cx="10572750" cy="742950"/>
+          </a:xfrm>
+          <a:prstGeom xmlns:a="http://schemas.openxmlformats.org/drawingml/2006/main" prst="rect">
+            <a:avLst/>
+          </a:prstGeom>
+          <a:noFill xmlns:a="http://schemas.openxmlformats.org/drawingml/2006/main"/>
+          <a:ln xmlns:a="http://schemas.openxmlformats.org/drawingml/2006/main" w="0">
+            <a:noFill/>
+          </a:ln>
+        </p:spPr>
+        <p:txBody>
+          <a:bodyPr xmlns:a="http://schemas.openxmlformats.org/drawingml/2006/main"/>
+          <a:lstStyle xmlns:a="http://schemas.openxmlformats.org/drawingml/2006/main">
+            <a:defPPr>
+              <a:defRPr sz="2025" b="0">
+                <a:solidFill>
+                  <a:srgbClr val="17324D"/>
+                </a:solidFill>
+                <a:latin typeface="DejaVu Sans"/>
+                <a:ea typeface="DejaVu Sans"/>
+                <a:cs typeface="DejaVu Sans"/>
+              </a:defRPr>
+            </a:defPPr>
+          </a:lstStyle>
+          <a:p xmlns:a="http://schemas.openxmlformats.org/drawingml/2006/main">
+            <a:pPr>
+              <a:buNone/>
+              <a:defRPr sz="2025" b="0">
+                <a:solidFill>
+                  <a:srgbClr val="17324D"/>
+                </a:solidFill>
+                <a:latin typeface="DejaVu Sans"/>
+                <a:ea typeface="DejaVu Sans"/>
+                <a:cs typeface="DejaVu Sans"/>
+              </a:defRPr>
+            </a:pPr>
+            <a:r>
+              <a:rPr sz="2025" b="0">
+                <a:solidFill>
+                  <a:srgbClr val="17324D"/>
+                </a:solidFill>
+                <a:latin typeface="DejaVu Sans"/>
+                <a:ea typeface="DejaVu Sans"/>
+                <a:cs typeface="DejaVu Sans"/>
+              </a:rPr>
+              <a:t>RGB plus human-coded behavior leads the tested development F1 comparison</a:t>
+            </a:r>
+          </a:p>
+        </p:txBody>
+      </p:sp>
+      <p:sp>
+        <p:nvSpPr>
+          <p:cNvPr id="4" name="">
+            <a:extLst xmlns:a="http://schemas.openxmlformats.org/drawingml/2006/main">
+              <a:ext uri="{FF2B5EF4-FFF2-40B4-BE49-F238E27FC236}">
+                <a16:creationId xmlns:a16="http://schemas.microsoft.com/office/drawing/2014/main" id="{043DBCC9-9C0C-4F7A-B594-8067CDF6D318}"/>
+              </a:ext>
+            </a:extLst>
+          </p:cNvPr>
+          <p:cNvSpPr>
+            <a:spLocks xmlns:a="http://schemas.openxmlformats.org/drawingml/2006/main" noGrp="1"/>
+          </p:cNvSpPr>
+          <p:nvPr/>
+        </p:nvSpPr>
+        <p:spPr>
+          <a:xfrm xmlns:a="http://schemas.openxmlformats.org/drawingml/2006/main">
+            <a:off x="714375" y="2505075"/>
+            <a:ext cx="10572750" cy="742950"/>
+          </a:xfrm>
+          <a:prstGeom xmlns:a="http://schemas.openxmlformats.org/drawingml/2006/main" prst="rect">
+            <a:avLst/>
+          </a:prstGeom>
+          <a:noFill xmlns:a="http://schemas.openxmlformats.org/drawingml/2006/main"/>
+          <a:ln xmlns:a="http://schemas.openxmlformats.org/drawingml/2006/main" w="0">
+            <a:noFill/>
+          </a:ln>
+        </p:spPr>
+        <p:txBody>
+          <a:bodyPr xmlns:a="http://schemas.openxmlformats.org/drawingml/2006/main"/>
+          <a:lstStyle xmlns:a="http://schemas.openxmlformats.org/drawingml/2006/main">
+            <a:defPPr>
+              <a:defRPr sz="2025" b="0">
+                <a:solidFill>
+                  <a:srgbClr val="17324D"/>
+                </a:solidFill>
+                <a:latin typeface="DejaVu Sans"/>
+                <a:ea typeface="DejaVu Sans"/>
+                <a:cs typeface="DejaVu Sans"/>
+              </a:defRPr>
+            </a:defPPr>
+          </a:lstStyle>
+          <a:p xmlns:a="http://schemas.openxmlformats.org/drawingml/2006/main">
+            <a:pPr>
+              <a:buNone/>
+              <a:defRPr sz="2025" b="0">
+                <a:solidFill>
+                  <a:srgbClr val="17324D"/>
+                </a:solidFill>
+                <a:latin typeface="DejaVu Sans"/>
+                <a:ea typeface="DejaVu Sans"/>
+                <a:cs typeface="DejaVu Sans"/>
+              </a:defRPr>
+            </a:pPr>
+            <a:r>
+              <a:rPr sz="2025" b="0">
+                <a:solidFill>
+                  <a:srgbClr val="17324D"/>
+                </a:solidFill>
+                <a:latin typeface="DejaVu Sans"/>
+                <a:ea typeface="DejaVu Sans"/>
+                <a:cs typeface="DejaVu Sans"/>
+              </a:rPr>
+              <a:t>Low precision and one positive test participant limit generalization</a:t>
+            </a:r>
+          </a:p>
+        </p:txBody>
+      </p:sp>
+      <p:sp>
+        <p:nvSpPr>
+          <p:cNvPr id="5" name="">
+            <a:extLst xmlns:a="http://schemas.openxmlformats.org/drawingml/2006/main">
+              <a:ext uri="{FF2B5EF4-FFF2-40B4-BE49-F238E27FC236}">
+                <a16:creationId xmlns:a16="http://schemas.microsoft.com/office/drawing/2014/main" id="{26EA96EB-7020-48D3-A489-9F6E1EC9DD33}"/>
+              </a:ext>
+            </a:extLst>
+          </p:cNvPr>
+          <p:cNvSpPr>
+            <a:spLocks xmlns:a="http://schemas.openxmlformats.org/drawingml/2006/main" noGrp="1"/>
+          </p:cNvSpPr>
+          <p:nvPr/>
+        </p:nvSpPr>
+        <p:spPr>
+          <a:xfrm xmlns:a="http://schemas.openxmlformats.org/drawingml/2006/main">
+            <a:off x="714375" y="3352800"/>
+            <a:ext cx="10572750" cy="742950"/>
+          </a:xfrm>
+          <a:prstGeom xmlns:a="http://schemas.openxmlformats.org/drawingml/2006/main" prst="rect">
+            <a:avLst/>
+          </a:prstGeom>
+          <a:noFill xmlns:a="http://schemas.openxmlformats.org/drawingml/2006/main"/>
+          <a:ln xmlns:a="http://schemas.openxmlformats.org/drawingml/2006/main" w="0">
+            <a:noFill/>
+          </a:ln>
+        </p:spPr>
+        <p:txBody>
+          <a:bodyPr xmlns:a="http://schemas.openxmlformats.org/drawingml/2006/main"/>
+          <a:lstStyle xmlns:a="http://schemas.openxmlformats.org/drawingml/2006/main">
+            <a:defPPr>
+              <a:defRPr sz="2025" b="0">
+                <a:solidFill>
+                  <a:srgbClr val="17324D"/>
+                </a:solidFill>
+                <a:latin typeface="DejaVu Sans"/>
+                <a:ea typeface="DejaVu Sans"/>
+                <a:cs typeface="DejaVu Sans"/>
+              </a:defRPr>
+            </a:defPPr>
+          </a:lstStyle>
+          <a:p xmlns:a="http://schemas.openxmlformats.org/drawingml/2006/main">
+            <a:pPr>
+              <a:buNone/>
+              <a:defRPr sz="2025" b="0">
+                <a:solidFill>
+                  <a:srgbClr val="17324D"/>
+                </a:solidFill>
+                <a:latin typeface="DejaVu Sans"/>
+                <a:ea typeface="DejaVu Sans"/>
+                <a:cs typeface="DejaVu Sans"/>
+              </a:defRPr>
+            </a:pPr>
+            <a:r>
+              <a:rPr sz="2025" b="0">
+                <a:solidFill>
+                  <a:srgbClr val="17324D"/>
+                </a:solidFill>
+                <a:latin typeface="DejaVu Sans"/>
+                <a:ea typeface="DejaVu Sans"/>
+                <a:cs typeface="DejaVu Sans"/>
+              </a:rPr>
+              <a:t>Prepared-feature and AV-ASD video pages provide model explanations</a:t>
+            </a:r>
+          </a:p>
+        </p:txBody>
+      </p:sp>
+      <p:sp>
+        <p:nvSpPr>
+          <p:cNvPr id="6" name="">
+            <a:extLst xmlns:a="http://schemas.openxmlformats.org/drawingml/2006/main">
+              <a:ext uri="{FF2B5EF4-FFF2-40B4-BE49-F238E27FC236}">
+                <a16:creationId xmlns:a16="http://schemas.microsoft.com/office/drawing/2014/main" id="{DE823F34-C468-49DC-9015-A56DFF4726AA}"/>
+              </a:ext>
+            </a:extLst>
+          </p:cNvPr>
+          <p:cNvSpPr>
+            <a:spLocks xmlns:a="http://schemas.openxmlformats.org/drawingml/2006/main" noGrp="1"/>
+          </p:cNvSpPr>
+          <p:nvPr/>
+        </p:nvSpPr>
+        <p:spPr>
+          <a:xfrm xmlns:a="http://schemas.openxmlformats.org/drawingml/2006/main">
+            <a:off x="714375" y="4200525"/>
+            <a:ext cx="10572750" cy="742950"/>
+          </a:xfrm>
+          <a:prstGeom xmlns:a="http://schemas.openxmlformats.org/drawingml/2006/main" prst="rect">
+            <a:avLst/>
+          </a:prstGeom>
+          <a:noFill xmlns:a="http://schemas.openxmlformats.org/drawingml/2006/main"/>
+          <a:ln xmlns:a="http://schemas.openxmlformats.org/drawingml/2006/main" w="0">
+            <a:noFill/>
+          </a:ln>
+        </p:spPr>
+        <p:txBody>
+          <a:bodyPr xmlns:a="http://schemas.openxmlformats.org/drawingml/2006/main"/>
+          <a:lstStyle xmlns:a="http://schemas.openxmlformats.org/drawingml/2006/main">
+            <a:defPPr>
+              <a:defRPr sz="2025" b="0">
+                <a:solidFill>
+                  <a:srgbClr val="17324D"/>
+                </a:solidFill>
+                <a:latin typeface="DejaVu Sans"/>
+                <a:ea typeface="DejaVu Sans"/>
+                <a:cs typeface="DejaVu Sans"/>
+              </a:defRPr>
+            </a:defPPr>
+          </a:lstStyle>
+          <a:p xmlns:a="http://schemas.openxmlformats.org/drawingml/2006/main">
+            <a:pPr>
+              <a:buNone/>
+              <a:defRPr sz="2025" b="0">
+                <a:solidFill>
+                  <a:srgbClr val="17324D"/>
+                </a:solidFill>
+                <a:latin typeface="DejaVu Sans"/>
+                <a:ea typeface="DejaVu Sans"/>
+                <a:cs typeface="DejaVu Sans"/>
+              </a:defRPr>
+            </a:pPr>
+            <a:r>
+              <a:rPr sz="2025" b="0">
+                <a:solidFill>
+                  <a:srgbClr val="17324D"/>
+                </a:solidFill>
+                <a:latin typeface="DejaVu Sans"/>
+                <a:ea typeface="DejaVu Sans"/>
+                <a:cs typeface="DejaVu Sans"/>
+              </a:rPr>
+              <a:t>Independent participant validation and provenance checks remain necessary</a:t>
+            </a:r>
+          </a:p>
+        </p:txBody>
+      </p:sp>
+      <p:sp>
+        <p:nvSpPr>
+          <p:cNvPr id="7" name="">
+            <a:extLst xmlns:a="http://schemas.openxmlformats.org/drawingml/2006/main">
+              <a:ext uri="{FF2B5EF4-FFF2-40B4-BE49-F238E27FC236}">
+                <a16:creationId xmlns:a16="http://schemas.microsoft.com/office/drawing/2014/main" id="{199F8B0F-0660-4429-BAB5-9E73228CF0CA}"/>
+              </a:ext>
+            </a:extLst>
+          </p:cNvPr>
+          <p:cNvSpPr>
+            <a:spLocks xmlns:a="http://schemas.openxmlformats.org/drawingml/2006/main" noGrp="1"/>
+          </p:cNvSpPr>
+          <p:nvPr/>
+        </p:nvSpPr>
+        <p:spPr>
+          <a:xfrm xmlns:a="http://schemas.openxmlformats.org/drawingml/2006/main">
+            <a:off x="714375" y="5048250"/>
+            <a:ext cx="10572750" cy="742950"/>
+          </a:xfrm>
+          <a:prstGeom xmlns:a="http://schemas.openxmlformats.org/drawingml/2006/main" prst="rect">
+            <a:avLst/>
+          </a:prstGeom>
+          <a:noFill xmlns:a="http://schemas.openxmlformats.org/drawingml/2006/main"/>
+          <a:ln xmlns:a="http://schemas.openxmlformats.org/drawingml/2006/main" w="0">
+            <a:noFill/>
+          </a:ln>
+        </p:spPr>
+        <p:txBody>
+          <a:bodyPr xmlns:a="http://schemas.openxmlformats.org/drawingml/2006/main"/>
+          <a:lstStyle xmlns:a="http://schemas.openxmlformats.org/drawingml/2006/main">
+            <a:defPPr>
+              <a:defRPr sz="2025" b="0">
+                <a:solidFill>
+                  <a:srgbClr val="17324D"/>
+                </a:solidFill>
+                <a:latin typeface="DejaVu Sans"/>
+                <a:ea typeface="DejaVu Sans"/>
+                <a:cs typeface="DejaVu Sans"/>
+              </a:defRPr>
+            </a:defPPr>
+          </a:lstStyle>
+          <a:p xmlns:a="http://schemas.openxmlformats.org/drawingml/2006/main">
+            <a:pPr>
+              <a:buNone/>
+              <a:defRPr sz="2025" b="0">
+                <a:solidFill>
+                  <a:srgbClr val="17324D"/>
+                </a:solidFill>
+                <a:latin typeface="DejaVu Sans"/>
+                <a:ea typeface="DejaVu Sans"/>
+                <a:cs typeface="DejaVu Sans"/>
+              </a:defRPr>
+            </a:pPr>
+            <a:r>
+              <a:rPr sz="2025" b="0">
+                <a:solidFill>
+                  <a:srgbClr val="17324D"/>
+                </a:solidFill>
+                <a:latin typeface="DejaVu Sans"/>
+                <a:ea typeface="DejaVu Sans"/>
+                <a:cs typeface="DejaVu Sans"/>
+              </a:rPr>
+              <a:t>ASD-FEAT raw-media integration and temporal models remain future work</a:t>
+            </a:r>
+          </a:p>
+        </p:txBody>
+      </p:sp>
+    </p:spTree>
+    <p:extLst>
+      <p:ext uri="{BB962C8B-B14F-4D97-AF65-F5344CB8AC3E}">
+        <p14:creationId xmlns:p14="http://schemas.microsoft.com/office/powerpoint/2010/main" val="1808176686"/>
       </p:ext>
     </p:extLst>
   </p:cSld>
@@ -5418,6 +6674,7 @@
           </a:lstStyle>
           <a:p xmlns:a="http://schemas.openxmlformats.org/drawingml/2006/main">
             <a:pPr>
+              <a:buNone/>
               <a:defRPr sz="3000" b="1">
                 <a:solidFill>
                   <a:srgbClr val="102A43"/>
@@ -5484,6 +6741,7 @@
           </a:lstStyle>
           <a:p xmlns:a="http://schemas.openxmlformats.org/drawingml/2006/main">
             <a:pPr>
+              <a:buNone/>
               <a:defRPr sz="1200" b="0">
                 <a:solidFill>
                   <a:srgbClr val="627D98"/>
@@ -5512,7 +6770,7 @@
           <p:cNvPr id="3" name="">
             <a:extLst xmlns:a="http://schemas.openxmlformats.org/drawingml/2006/main">
               <a:ext uri="{FF2B5EF4-FFF2-40B4-BE49-F238E27FC236}">
-                <a16:creationId xmlns:a16="http://schemas.microsoft.com/office/drawing/2014/main" id="{505C81BC-90A7-4BEB-9F61-0CE896D688A4}"/>
+                <a16:creationId xmlns:a16="http://schemas.microsoft.com/office/drawing/2014/main" id="{1CF0CB39-7FF9-4486-874A-6CF68D6E2DA3}"/>
               </a:ext>
             </a:extLst>
           </p:cNvPr>
@@ -5801,6 +7059,7 @@
           </a:lstStyle>
           <a:p xmlns:a="http://schemas.openxmlformats.org/drawingml/2006/main">
             <a:pPr>
+              <a:buNone/>
               <a:defRPr sz="2175" b="0">
                 <a:solidFill>
                   <a:srgbClr val="17324D"/>
@@ -5867,6 +7126,7 @@
           </a:lstStyle>
           <a:p xmlns:a="http://schemas.openxmlformats.org/drawingml/2006/main">
             <a:pPr>
+              <a:buNone/>
               <a:defRPr sz="1875" b="0">
                 <a:solidFill>
                   <a:srgbClr val="17324D"/>
@@ -5962,6 +7222,7 @@
           </a:lstStyle>
           <a:p xmlns:a="http://schemas.openxmlformats.org/drawingml/2006/main">
             <a:pPr>
+              <a:buNone/>
               <a:defRPr sz="3000" b="1">
                 <a:solidFill>
                   <a:srgbClr val="102A43"/>
@@ -6028,6 +7289,7 @@
           </a:lstStyle>
           <a:p xmlns:a="http://schemas.openxmlformats.org/drawingml/2006/main">
             <a:pPr>
+              <a:buNone/>
               <a:defRPr sz="1200" b="0">
                 <a:solidFill>
                   <a:srgbClr val="627D98"/>
@@ -6094,6 +7356,7 @@
           </a:lstStyle>
           <a:p xmlns:a="http://schemas.openxmlformats.org/drawingml/2006/main">
             <a:pPr>
+              <a:buNone/>
               <a:defRPr sz="2025" b="0">
                 <a:solidFill>
                   <a:srgbClr val="17324D"/>
@@ -6160,6 +7423,7 @@
           </a:lstStyle>
           <a:p xmlns:a="http://schemas.openxmlformats.org/drawingml/2006/main">
             <a:pPr>
+              <a:buNone/>
               <a:defRPr sz="2025" b="0">
                 <a:solidFill>
                   <a:srgbClr val="17324D"/>
@@ -6226,6 +7490,7 @@
           </a:lstStyle>
           <a:p xmlns:a="http://schemas.openxmlformats.org/drawingml/2006/main">
             <a:pPr>
+              <a:buNone/>
               <a:defRPr sz="2025" b="0">
                 <a:solidFill>
                   <a:srgbClr val="17324D"/>
@@ -6292,6 +7557,7 @@
           </a:lstStyle>
           <a:p xmlns:a="http://schemas.openxmlformats.org/drawingml/2006/main">
             <a:pPr>
+              <a:buNone/>
               <a:defRPr sz="2025" b="0">
                 <a:solidFill>
                   <a:srgbClr val="17324D"/>
@@ -6358,6 +7624,7 @@
           </a:lstStyle>
           <a:p xmlns:a="http://schemas.openxmlformats.org/drawingml/2006/main">
             <a:pPr>
+              <a:buNone/>
               <a:defRPr sz="2025" b="0">
                 <a:solidFill>
                   <a:srgbClr val="17324D"/>
@@ -6453,6 +7720,7 @@
           </a:lstStyle>
           <a:p xmlns:a="http://schemas.openxmlformats.org/drawingml/2006/main">
             <a:pPr>
+              <a:buNone/>
               <a:defRPr sz="3000" b="1">
                 <a:solidFill>
                   <a:srgbClr val="102A43"/>
@@ -6519,6 +7787,7 @@
           </a:lstStyle>
           <a:p xmlns:a="http://schemas.openxmlformats.org/drawingml/2006/main">
             <a:pPr>
+              <a:buNone/>
               <a:defRPr sz="1200" b="0">
                 <a:solidFill>
                   <a:srgbClr val="627D98"/>
@@ -6585,6 +7854,7 @@
           </a:lstStyle>
           <a:p xmlns:a="http://schemas.openxmlformats.org/drawingml/2006/main">
             <a:pPr>
+              <a:buNone/>
               <a:defRPr sz="2025" b="0">
                 <a:solidFill>
                   <a:srgbClr val="17324D"/>
@@ -6651,6 +7921,7 @@
           </a:lstStyle>
           <a:p xmlns:a="http://schemas.openxmlformats.org/drawingml/2006/main">
             <a:pPr>
+              <a:buNone/>
               <a:defRPr sz="2025" b="0">
                 <a:solidFill>
                   <a:srgbClr val="17324D"/>
@@ -6717,6 +7988,7 @@
           </a:lstStyle>
           <a:p xmlns:a="http://schemas.openxmlformats.org/drawingml/2006/main">
             <a:pPr>
+              <a:buNone/>
               <a:defRPr sz="2025" b="0">
                 <a:solidFill>
                   <a:srgbClr val="17324D"/>
@@ -6783,6 +8055,7 @@
           </a:lstStyle>
           <a:p xmlns:a="http://schemas.openxmlformats.org/drawingml/2006/main">
             <a:pPr>
+              <a:buNone/>
               <a:defRPr sz="2025" b="0">
                 <a:solidFill>
                   <a:srgbClr val="17324D"/>
@@ -6849,6 +8122,7 @@
           </a:lstStyle>
           <a:p xmlns:a="http://schemas.openxmlformats.org/drawingml/2006/main">
             <a:pPr>
+              <a:buNone/>
               <a:defRPr sz="2025" b="0">
                 <a:solidFill>
                   <a:srgbClr val="17324D"/>
@@ -6944,6 +8218,7 @@
           </a:lstStyle>
           <a:p xmlns:a="http://schemas.openxmlformats.org/drawingml/2006/main">
             <a:pPr>
+              <a:buNone/>
               <a:defRPr sz="3000" b="1">
                 <a:solidFill>
                   <a:srgbClr val="102A43"/>
@@ -7010,6 +8285,7 @@
           </a:lstStyle>
           <a:p xmlns:a="http://schemas.openxmlformats.org/drawingml/2006/main">
             <a:pPr>
+              <a:buNone/>
               <a:defRPr sz="1200" b="0">
                 <a:solidFill>
                   <a:srgbClr val="627D98"/>
@@ -7038,7 +8314,7 @@
           <p:cNvPr id="3" name="">
             <a:extLst xmlns:a="http://schemas.openxmlformats.org/drawingml/2006/main">
               <a:ext uri="{FF2B5EF4-FFF2-40B4-BE49-F238E27FC236}">
-                <a16:creationId xmlns:a16="http://schemas.microsoft.com/office/drawing/2014/main" id="{5396D77F-E6F4-45FC-B2B2-CC0A753CE40A}"/>
+                <a16:creationId xmlns:a16="http://schemas.microsoft.com/office/drawing/2014/main" id="{EE0D3808-F334-4DA0-BF0C-F4A2FBD5E0AC}"/>
               </a:ext>
             </a:extLst>
           </p:cNvPr>
@@ -7623,6 +8899,7 @@
           </a:lstStyle>
           <a:p xmlns:a="http://schemas.openxmlformats.org/drawingml/2006/main">
             <a:pPr>
+              <a:buNone/>
               <a:defRPr sz="1875" b="0">
                 <a:solidFill>
                   <a:srgbClr val="17324D"/>
@@ -7718,6 +8995,7 @@
           </a:lstStyle>
           <a:p xmlns:a="http://schemas.openxmlformats.org/drawingml/2006/main">
             <a:pPr>
+              <a:buNone/>
               <a:defRPr sz="3000" b="1">
                 <a:solidFill>
                   <a:srgbClr val="102A43"/>
@@ -7784,6 +9062,7 @@
           </a:lstStyle>
           <a:p xmlns:a="http://schemas.openxmlformats.org/drawingml/2006/main">
             <a:pPr>
+              <a:buNone/>
               <a:defRPr sz="1200" b="0">
                 <a:solidFill>
                   <a:srgbClr val="627D98"/>
@@ -7812,7 +9091,7 @@
           <p:cNvPr id="3" name="">
             <a:extLst xmlns:a="http://schemas.openxmlformats.org/drawingml/2006/main">
               <a:ext uri="{FF2B5EF4-FFF2-40B4-BE49-F238E27FC236}">
-                <a16:creationId xmlns:a16="http://schemas.microsoft.com/office/drawing/2014/main" id="{0FFA0398-FF92-4789-BC16-0EE497AC8615}"/>
+                <a16:creationId xmlns:a16="http://schemas.microsoft.com/office/drawing/2014/main" id="{683F6C0F-20AA-4C98-BF13-444A28CA5352}"/>
               </a:ext>
             </a:extLst>
           </p:cNvPr>
@@ -8249,6 +9528,7 @@
           </a:lstStyle>
           <a:p xmlns:a="http://schemas.openxmlformats.org/drawingml/2006/main">
             <a:pPr>
+              <a:buNone/>
               <a:defRPr sz="1875" b="0">
                 <a:solidFill>
                   <a:srgbClr val="17324D"/>
@@ -8315,6 +9595,7 @@
           </a:lstStyle>
           <a:p xmlns:a="http://schemas.openxmlformats.org/drawingml/2006/main">
             <a:pPr>
+              <a:buNone/>
               <a:defRPr sz="1800" b="0">
                 <a:solidFill>
                   <a:srgbClr val="17324D"/>
@@ -8410,6 +9691,7 @@
           </a:lstStyle>
           <a:p xmlns:a="http://schemas.openxmlformats.org/drawingml/2006/main">
             <a:pPr>
+              <a:buNone/>
               <a:defRPr sz="3000" b="1">
                 <a:solidFill>
                   <a:srgbClr val="102A43"/>
@@ -8476,6 +9758,7 @@
           </a:lstStyle>
           <a:p xmlns:a="http://schemas.openxmlformats.org/drawingml/2006/main">
             <a:pPr>
+              <a:buNone/>
               <a:defRPr sz="1200" b="0">
                 <a:solidFill>
                   <a:srgbClr val="627D98"/>
@@ -8542,6 +9825,7 @@
           </a:lstStyle>
           <a:p xmlns:a="http://schemas.openxmlformats.org/drawingml/2006/main">
             <a:pPr>
+              <a:buNone/>
               <a:defRPr sz="2025" b="0">
                 <a:solidFill>
                   <a:srgbClr val="17324D"/>
@@ -8608,6 +9892,7 @@
           </a:lstStyle>
           <a:p xmlns:a="http://schemas.openxmlformats.org/drawingml/2006/main">
             <a:pPr>
+              <a:buNone/>
               <a:defRPr sz="2025" b="0">
                 <a:solidFill>
                   <a:srgbClr val="17324D"/>
@@ -8674,6 +9959,7 @@
           </a:lstStyle>
           <a:p xmlns:a="http://schemas.openxmlformats.org/drawingml/2006/main">
             <a:pPr>
+              <a:buNone/>
               <a:defRPr sz="2025" b="0">
                 <a:solidFill>
                   <a:srgbClr val="17324D"/>
@@ -8740,6 +10026,7 @@
           </a:lstStyle>
           <a:p xmlns:a="http://schemas.openxmlformats.org/drawingml/2006/main">
             <a:pPr>
+              <a:buNone/>
               <a:defRPr sz="2025" b="0">
                 <a:solidFill>
                   <a:srgbClr val="17324D"/>
@@ -8806,6 +10093,7 @@
           </a:lstStyle>
           <a:p xmlns:a="http://schemas.openxmlformats.org/drawingml/2006/main">
             <a:pPr>
+              <a:buNone/>
               <a:defRPr sz="2025" b="0">
                 <a:solidFill>
                   <a:srgbClr val="17324D"/>
@@ -8901,6 +10189,7 @@
           </a:lstStyle>
           <a:p xmlns:a="http://schemas.openxmlformats.org/drawingml/2006/main">
             <a:pPr>
+              <a:buNone/>
               <a:defRPr sz="3000" b="1">
                 <a:solidFill>
                   <a:srgbClr val="102A43"/>
@@ -8967,6 +10256,7 @@
           </a:lstStyle>
           <a:p xmlns:a="http://schemas.openxmlformats.org/drawingml/2006/main">
             <a:pPr>
+              <a:buNone/>
               <a:defRPr sz="1200" b="0">
                 <a:solidFill>
                   <a:srgbClr val="627D98"/>
@@ -8995,7 +10285,7 @@
           <p:cNvPr id="3" name="">
             <a:extLst xmlns:a="http://schemas.openxmlformats.org/drawingml/2006/main">
               <a:ext uri="{FF2B5EF4-FFF2-40B4-BE49-F238E27FC236}">
-                <a16:creationId xmlns:a16="http://schemas.microsoft.com/office/drawing/2014/main" id="{01D9F032-3B20-4634-BEB8-27FFDB922306}"/>
+                <a16:creationId xmlns:a16="http://schemas.microsoft.com/office/drawing/2014/main" id="{697BF068-8959-46F6-8A5D-948AB35F1075}"/>
               </a:ext>
             </a:extLst>
           </p:cNvPr>
@@ -9411,6 +10701,7 @@
           </a:lstStyle>
           <a:p xmlns:a="http://schemas.openxmlformats.org/drawingml/2006/main">
             <a:pPr>
+              <a:buNone/>
               <a:defRPr sz="1875" b="0">
                 <a:solidFill>
                   <a:srgbClr val="17324D"/>
@@ -9477,6 +10768,7 @@
           </a:lstStyle>
           <a:p xmlns:a="http://schemas.openxmlformats.org/drawingml/2006/main">
             <a:pPr>
+              <a:buNone/>
               <a:defRPr sz="1950" b="1">
                 <a:solidFill>
                   <a:srgbClr val="9C2F22"/>
@@ -9572,6 +10864,7 @@
           </a:lstStyle>
           <a:p xmlns:a="http://schemas.openxmlformats.org/drawingml/2006/main">
             <a:pPr>
+              <a:buNone/>
               <a:defRPr sz="3000" b="1">
                 <a:solidFill>
                   <a:srgbClr val="102A43"/>
@@ -9638,6 +10931,7 @@
           </a:lstStyle>
           <a:p xmlns:a="http://schemas.openxmlformats.org/drawingml/2006/main">
             <a:pPr>
+              <a:buNone/>
               <a:defRPr sz="1200" b="0">
                 <a:solidFill>
                   <a:srgbClr val="627D98"/>
@@ -9666,7 +10960,7 @@
           <p:cNvPr id="3" name="">
             <a:extLst xmlns:a="http://schemas.openxmlformats.org/drawingml/2006/main">
               <a:ext uri="{FF2B5EF4-FFF2-40B4-BE49-F238E27FC236}">
-                <a16:creationId xmlns:a16="http://schemas.microsoft.com/office/drawing/2014/main" id="{B9620606-27D9-4A58-B3B2-20D23654AB14}"/>
+                <a16:creationId xmlns:a16="http://schemas.microsoft.com/office/drawing/2014/main" id="{2BCEC286-B022-4D8C-B6EB-90E600BFA2B1}"/>
               </a:ext>
             </a:extLst>
           </p:cNvPr>
@@ -10177,6 +11471,7 @@
           </a:lstStyle>
           <a:p xmlns:a="http://schemas.openxmlformats.org/drawingml/2006/main">
             <a:pPr>
+              <a:buNone/>
               <a:defRPr sz="1875" b="0">
                 <a:solidFill>
                   <a:srgbClr val="17324D"/>
@@ -10243,6 +11538,7 @@
           </a:lstStyle>
           <a:p xmlns:a="http://schemas.openxmlformats.org/drawingml/2006/main">
             <a:pPr>
+              <a:buNone/>
               <a:defRPr sz="1800" b="0">
                 <a:solidFill>
                   <a:srgbClr val="17324D"/>

</xml_diff>